<commit_message>
Multibody added mass model and paper scripts/figures
</commit_message>
<xml_diff>
--- a/examples/FOSWEC_M4E/FOSWEC_BEM_Dimensions.pptx
+++ b/examples/FOSWEC_M4E/FOSWEC_BEM_Dimensions.pptx
@@ -9,6 +9,7 @@
     <p:sldId id="258" r:id="rId3"/>
     <p:sldId id="259" r:id="rId4"/>
     <p:sldId id="260" r:id="rId5"/>
+    <p:sldId id="261" r:id="rId6"/>
   </p:sldIdLst>
   <p:sldSz cx="12192000" cy="6858000"/>
   <p:notesSz cx="6858000" cy="9144000"/>
@@ -150,7 +151,7 @@
         </p:nvSpPr>
         <p:spPr>
           <a:xfrm>
-            <a:off x="1524000" y="1122363"/>
+            <a:off x="1524001" y="1122363"/>
             <a:ext cx="9144000" cy="2387600"/>
           </a:xfrm>
         </p:spPr>
@@ -158,7 +159,7 @@
           <a:bodyPr anchor="b"/>
           <a:lstStyle>
             <a:lvl1pPr algn="ctr">
-              <a:defRPr sz="6000"/>
+              <a:defRPr sz="5999"/>
             </a:lvl1pPr>
           </a:lstStyle>
           <a:p>
@@ -187,7 +188,7 @@
         </p:nvSpPr>
         <p:spPr>
           <a:xfrm>
-            <a:off x="1524000" y="3602038"/>
+            <a:off x="1524001" y="3602038"/>
             <a:ext cx="9144000" cy="1655762"/>
           </a:xfrm>
         </p:spPr>
@@ -198,35 +199,35 @@
               <a:buNone/>
               <a:defRPr sz="2400"/>
             </a:lvl1pPr>
-            <a:lvl2pPr marL="457200" indent="0" algn="ctr">
+            <a:lvl2pPr marL="457172" indent="0" algn="ctr">
               <a:buNone/>
               <a:defRPr sz="2000"/>
             </a:lvl2pPr>
-            <a:lvl3pPr marL="914400" indent="0" algn="ctr">
+            <a:lvl3pPr marL="914344" indent="0" algn="ctr">
               <a:buNone/>
-              <a:defRPr sz="1800"/>
+              <a:defRPr sz="1799"/>
             </a:lvl3pPr>
-            <a:lvl4pPr marL="1371600" indent="0" algn="ctr">
+            <a:lvl4pPr marL="1371516" indent="0" algn="ctr">
               <a:buNone/>
               <a:defRPr sz="1600"/>
             </a:lvl4pPr>
-            <a:lvl5pPr marL="1828800" indent="0" algn="ctr">
+            <a:lvl5pPr marL="1828687" indent="0" algn="ctr">
               <a:buNone/>
               <a:defRPr sz="1600"/>
             </a:lvl5pPr>
-            <a:lvl6pPr marL="2286000" indent="0" algn="ctr">
+            <a:lvl6pPr marL="2285859" indent="0" algn="ctr">
               <a:buNone/>
               <a:defRPr sz="1600"/>
             </a:lvl6pPr>
-            <a:lvl7pPr marL="2743200" indent="0" algn="ctr">
+            <a:lvl7pPr marL="2743032" indent="0" algn="ctr">
               <a:buNone/>
               <a:defRPr sz="1600"/>
             </a:lvl7pPr>
-            <a:lvl8pPr marL="3200400" indent="0" algn="ctr">
+            <a:lvl8pPr marL="3200203" indent="0" algn="ctr">
               <a:buNone/>
               <a:defRPr sz="1600"/>
             </a:lvl8pPr>
-            <a:lvl9pPr marL="3657600" indent="0" algn="ctr">
+            <a:lvl9pPr marL="3657375" indent="0" algn="ctr">
               <a:buNone/>
               <a:defRPr sz="1600"/>
             </a:lvl9pPr>
@@ -262,7 +263,7 @@
           <a:p>
             <a:fld id="{DC3DD596-B551-4104-AF86-405EBC7207B6}" type="datetimeFigureOut">
               <a:rPr lang="en-US" smtClean="0"/>
-              <a:t>6/26/2026</a:t>
+              <a:t>7/31/2026</a:t>
             </a:fld>
             <a:endParaRPr lang="en-US"/>
           </a:p>
@@ -460,7 +461,7 @@
           <a:p>
             <a:fld id="{DC3DD596-B551-4104-AF86-405EBC7207B6}" type="datetimeFigureOut">
               <a:rPr lang="en-US" smtClean="0"/>
-              <a:t>6/26/2026</a:t>
+              <a:t>7/31/2026</a:t>
             </a:fld>
             <a:endParaRPr lang="en-US"/>
           </a:p>
@@ -568,7 +569,7 @@
         </p:nvSpPr>
         <p:spPr>
           <a:xfrm>
-            <a:off x="8724900" y="365125"/>
+            <a:off x="8724901" y="365125"/>
             <a:ext cx="2628900" cy="5811838"/>
           </a:xfrm>
         </p:spPr>
@@ -601,7 +602,7 @@
         </p:nvSpPr>
         <p:spPr>
           <a:xfrm>
-            <a:off x="838200" y="365125"/>
+            <a:off x="838201" y="365125"/>
             <a:ext cx="7734300" cy="5811838"/>
           </a:xfrm>
         </p:spPr>
@@ -668,7 +669,7 @@
           <a:p>
             <a:fld id="{DC3DD596-B551-4104-AF86-405EBC7207B6}" type="datetimeFigureOut">
               <a:rPr lang="en-US" smtClean="0"/>
-              <a:t>6/26/2026</a:t>
+              <a:t>7/31/2026</a:t>
             </a:fld>
             <a:endParaRPr lang="en-US"/>
           </a:p>
@@ -866,7 +867,7 @@
           <a:p>
             <a:fld id="{DC3DD596-B551-4104-AF86-405EBC7207B6}" type="datetimeFigureOut">
               <a:rPr lang="en-US" smtClean="0"/>
-              <a:t>6/26/2026</a:t>
+              <a:t>7/31/2026</a:t>
             </a:fld>
             <a:endParaRPr lang="en-US"/>
           </a:p>
@@ -974,7 +975,7 @@
         </p:nvSpPr>
         <p:spPr>
           <a:xfrm>
-            <a:off x="831850" y="1709738"/>
+            <a:off x="831850" y="1709740"/>
             <a:ext cx="10515600" cy="2852737"/>
           </a:xfrm>
         </p:spPr>
@@ -982,7 +983,7 @@
           <a:bodyPr anchor="b"/>
           <a:lstStyle>
             <a:lvl1pPr>
-              <a:defRPr sz="6000"/>
+              <a:defRPr sz="5999"/>
             </a:lvl1pPr>
           </a:lstStyle>
           <a:p>
@@ -1011,7 +1012,7 @@
         </p:nvSpPr>
         <p:spPr>
           <a:xfrm>
-            <a:off x="831850" y="4589463"/>
+            <a:off x="831850" y="4589465"/>
             <a:ext cx="10515600" cy="1500187"/>
           </a:xfrm>
         </p:spPr>
@@ -1028,7 +1029,7 @@
                 </a:solidFill>
               </a:defRPr>
             </a:lvl1pPr>
-            <a:lvl2pPr marL="457200" indent="0">
+            <a:lvl2pPr marL="457172" indent="0">
               <a:buNone/>
               <a:defRPr sz="2000">
                 <a:solidFill>
@@ -1038,9 +1039,9 @@
                 </a:solidFill>
               </a:defRPr>
             </a:lvl2pPr>
-            <a:lvl3pPr marL="914400" indent="0">
+            <a:lvl3pPr marL="914344" indent="0">
               <a:buNone/>
-              <a:defRPr sz="1800">
+              <a:defRPr sz="1799">
                 <a:solidFill>
                   <a:schemeClr val="tx1">
                     <a:tint val="82000"/>
@@ -1048,7 +1049,7 @@
                 </a:solidFill>
               </a:defRPr>
             </a:lvl3pPr>
-            <a:lvl4pPr marL="1371600" indent="0">
+            <a:lvl4pPr marL="1371516" indent="0">
               <a:buNone/>
               <a:defRPr sz="1600">
                 <a:solidFill>
@@ -1058,7 +1059,7 @@
                 </a:solidFill>
               </a:defRPr>
             </a:lvl4pPr>
-            <a:lvl5pPr marL="1828800" indent="0">
+            <a:lvl5pPr marL="1828687" indent="0">
               <a:buNone/>
               <a:defRPr sz="1600">
                 <a:solidFill>
@@ -1068,7 +1069,7 @@
                 </a:solidFill>
               </a:defRPr>
             </a:lvl5pPr>
-            <a:lvl6pPr marL="2286000" indent="0">
+            <a:lvl6pPr marL="2285859" indent="0">
               <a:buNone/>
               <a:defRPr sz="1600">
                 <a:solidFill>
@@ -1078,7 +1079,7 @@
                 </a:solidFill>
               </a:defRPr>
             </a:lvl6pPr>
-            <a:lvl7pPr marL="2743200" indent="0">
+            <a:lvl7pPr marL="2743032" indent="0">
               <a:buNone/>
               <a:defRPr sz="1600">
                 <a:solidFill>
@@ -1088,7 +1089,7 @@
                 </a:solidFill>
               </a:defRPr>
             </a:lvl7pPr>
-            <a:lvl8pPr marL="3200400" indent="0">
+            <a:lvl8pPr marL="3200203" indent="0">
               <a:buNone/>
               <a:defRPr sz="1600">
                 <a:solidFill>
@@ -1098,7 +1099,7 @@
                 </a:solidFill>
               </a:defRPr>
             </a:lvl8pPr>
-            <a:lvl9pPr marL="3657600" indent="0">
+            <a:lvl9pPr marL="3657375" indent="0">
               <a:buNone/>
               <a:defRPr sz="1600">
                 <a:solidFill>
@@ -1141,7 +1142,7 @@
           <a:p>
             <a:fld id="{DC3DD596-B551-4104-AF86-405EBC7207B6}" type="datetimeFigureOut">
               <a:rPr lang="en-US" smtClean="0"/>
-              <a:t>6/26/2026</a:t>
+              <a:t>7/31/2026</a:t>
             </a:fld>
             <a:endParaRPr lang="en-US"/>
           </a:p>
@@ -1406,7 +1407,7 @@
           <a:p>
             <a:fld id="{DC3DD596-B551-4104-AF86-405EBC7207B6}" type="datetimeFigureOut">
               <a:rPr lang="en-US" smtClean="0"/>
-              <a:t>6/26/2026</a:t>
+              <a:t>7/31/2026</a:t>
             </a:fld>
             <a:endParaRPr lang="en-US"/>
           </a:p>
@@ -1514,7 +1515,7 @@
         </p:nvSpPr>
         <p:spPr>
           <a:xfrm>
-            <a:off x="839788" y="365125"/>
+            <a:off x="839789" y="365127"/>
             <a:ext cx="10515600" cy="1325563"/>
           </a:xfrm>
         </p:spPr>
@@ -1558,35 +1559,35 @@
               <a:buNone/>
               <a:defRPr sz="2400" b="1"/>
             </a:lvl1pPr>
-            <a:lvl2pPr marL="457200" indent="0">
+            <a:lvl2pPr marL="457172" indent="0">
               <a:buNone/>
               <a:defRPr sz="2000" b="1"/>
             </a:lvl2pPr>
-            <a:lvl3pPr marL="914400" indent="0">
+            <a:lvl3pPr marL="914344" indent="0">
               <a:buNone/>
-              <a:defRPr sz="1800" b="1"/>
+              <a:defRPr sz="1799" b="1"/>
             </a:lvl3pPr>
-            <a:lvl4pPr marL="1371600" indent="0">
+            <a:lvl4pPr marL="1371516" indent="0">
               <a:buNone/>
               <a:defRPr sz="1600" b="1"/>
             </a:lvl4pPr>
-            <a:lvl5pPr marL="1828800" indent="0">
+            <a:lvl5pPr marL="1828687" indent="0">
               <a:buNone/>
               <a:defRPr sz="1600" b="1"/>
             </a:lvl5pPr>
-            <a:lvl6pPr marL="2286000" indent="0">
+            <a:lvl6pPr marL="2285859" indent="0">
               <a:buNone/>
               <a:defRPr sz="1600" b="1"/>
             </a:lvl6pPr>
-            <a:lvl7pPr marL="2743200" indent="0">
+            <a:lvl7pPr marL="2743032" indent="0">
               <a:buNone/>
               <a:defRPr sz="1600" b="1"/>
             </a:lvl7pPr>
-            <a:lvl8pPr marL="3200400" indent="0">
+            <a:lvl8pPr marL="3200203" indent="0">
               <a:buNone/>
               <a:defRPr sz="1600" b="1"/>
             </a:lvl8pPr>
-            <a:lvl9pPr marL="3657600" indent="0">
+            <a:lvl9pPr marL="3657375" indent="0">
               <a:buNone/>
               <a:defRPr sz="1600" b="1"/>
             </a:lvl9pPr>
@@ -1680,7 +1681,7 @@
         </p:nvSpPr>
         <p:spPr>
           <a:xfrm>
-            <a:off x="6172200" y="1681163"/>
+            <a:off x="6172201" y="1681163"/>
             <a:ext cx="5183188" cy="823912"/>
           </a:xfrm>
         </p:spPr>
@@ -1691,35 +1692,35 @@
               <a:buNone/>
               <a:defRPr sz="2400" b="1"/>
             </a:lvl1pPr>
-            <a:lvl2pPr marL="457200" indent="0">
+            <a:lvl2pPr marL="457172" indent="0">
               <a:buNone/>
               <a:defRPr sz="2000" b="1"/>
             </a:lvl2pPr>
-            <a:lvl3pPr marL="914400" indent="0">
+            <a:lvl3pPr marL="914344" indent="0">
               <a:buNone/>
-              <a:defRPr sz="1800" b="1"/>
+              <a:defRPr sz="1799" b="1"/>
             </a:lvl3pPr>
-            <a:lvl4pPr marL="1371600" indent="0">
+            <a:lvl4pPr marL="1371516" indent="0">
               <a:buNone/>
               <a:defRPr sz="1600" b="1"/>
             </a:lvl4pPr>
-            <a:lvl5pPr marL="1828800" indent="0">
+            <a:lvl5pPr marL="1828687" indent="0">
               <a:buNone/>
               <a:defRPr sz="1600" b="1"/>
             </a:lvl5pPr>
-            <a:lvl6pPr marL="2286000" indent="0">
+            <a:lvl6pPr marL="2285859" indent="0">
               <a:buNone/>
               <a:defRPr sz="1600" b="1"/>
             </a:lvl6pPr>
-            <a:lvl7pPr marL="2743200" indent="0">
+            <a:lvl7pPr marL="2743032" indent="0">
               <a:buNone/>
               <a:defRPr sz="1600" b="1"/>
             </a:lvl7pPr>
-            <a:lvl8pPr marL="3200400" indent="0">
+            <a:lvl8pPr marL="3200203" indent="0">
               <a:buNone/>
               <a:defRPr sz="1600" b="1"/>
             </a:lvl8pPr>
-            <a:lvl9pPr marL="3657600" indent="0">
+            <a:lvl9pPr marL="3657375" indent="0">
               <a:buNone/>
               <a:defRPr sz="1600" b="1"/>
             </a:lvl9pPr>
@@ -1751,7 +1752,7 @@
         </p:nvSpPr>
         <p:spPr>
           <a:xfrm>
-            <a:off x="6172200" y="2505075"/>
+            <a:off x="6172201" y="2505075"/>
             <a:ext cx="5183188" cy="3684588"/>
           </a:xfrm>
         </p:spPr>
@@ -1818,7 +1819,7 @@
           <a:p>
             <a:fld id="{DC3DD596-B551-4104-AF86-405EBC7207B6}" type="datetimeFigureOut">
               <a:rPr lang="en-US" smtClean="0"/>
-              <a:t>6/26/2026</a:t>
+              <a:t>7/31/2026</a:t>
             </a:fld>
             <a:endParaRPr lang="en-US"/>
           </a:p>
@@ -1959,7 +1960,7 @@
           <a:p>
             <a:fld id="{DC3DD596-B551-4104-AF86-405EBC7207B6}" type="datetimeFigureOut">
               <a:rPr lang="en-US" smtClean="0"/>
-              <a:t>6/26/2026</a:t>
+              <a:t>7/31/2026</a:t>
             </a:fld>
             <a:endParaRPr lang="en-US"/>
           </a:p>
@@ -2072,7 +2073,7 @@
           <a:p>
             <a:fld id="{DC3DD596-B551-4104-AF86-405EBC7207B6}" type="datetimeFigureOut">
               <a:rPr lang="en-US" smtClean="0"/>
-              <a:t>6/26/2026</a:t>
+              <a:t>7/31/2026</a:t>
             </a:fld>
             <a:endParaRPr lang="en-US"/>
           </a:p>
@@ -2180,7 +2181,7 @@
         </p:nvSpPr>
         <p:spPr>
           <a:xfrm>
-            <a:off x="839788" y="457200"/>
+            <a:off x="839789" y="457200"/>
             <a:ext cx="3932237" cy="1600200"/>
           </a:xfrm>
         </p:spPr>
@@ -2217,7 +2218,7 @@
         </p:nvSpPr>
         <p:spPr>
           <a:xfrm>
-            <a:off x="5183188" y="987425"/>
+            <a:off x="5183188" y="987427"/>
             <a:ext cx="6172200" cy="4873625"/>
           </a:xfrm>
         </p:spPr>
@@ -2307,7 +2308,7 @@
         </p:nvSpPr>
         <p:spPr>
           <a:xfrm>
-            <a:off x="839788" y="2057400"/>
+            <a:off x="839789" y="2057400"/>
             <a:ext cx="3932237" cy="3811588"/>
           </a:xfrm>
         </p:spPr>
@@ -2318,37 +2319,37 @@
               <a:buNone/>
               <a:defRPr sz="1600"/>
             </a:lvl1pPr>
-            <a:lvl2pPr marL="457200" indent="0">
+            <a:lvl2pPr marL="457172" indent="0">
               <a:buNone/>
-              <a:defRPr sz="1400"/>
+              <a:defRPr sz="1399"/>
             </a:lvl2pPr>
-            <a:lvl3pPr marL="914400" indent="0">
+            <a:lvl3pPr marL="914344" indent="0">
               <a:buNone/>
               <a:defRPr sz="1200"/>
             </a:lvl3pPr>
-            <a:lvl4pPr marL="1371600" indent="0">
+            <a:lvl4pPr marL="1371516" indent="0">
               <a:buNone/>
-              <a:defRPr sz="1000"/>
+              <a:defRPr sz="999"/>
             </a:lvl4pPr>
-            <a:lvl5pPr marL="1828800" indent="0">
+            <a:lvl5pPr marL="1828687" indent="0">
               <a:buNone/>
-              <a:defRPr sz="1000"/>
+              <a:defRPr sz="999"/>
             </a:lvl5pPr>
-            <a:lvl6pPr marL="2286000" indent="0">
+            <a:lvl6pPr marL="2285859" indent="0">
               <a:buNone/>
-              <a:defRPr sz="1000"/>
+              <a:defRPr sz="999"/>
             </a:lvl6pPr>
-            <a:lvl7pPr marL="2743200" indent="0">
+            <a:lvl7pPr marL="2743032" indent="0">
               <a:buNone/>
-              <a:defRPr sz="1000"/>
+              <a:defRPr sz="999"/>
             </a:lvl7pPr>
-            <a:lvl8pPr marL="3200400" indent="0">
+            <a:lvl8pPr marL="3200203" indent="0">
               <a:buNone/>
-              <a:defRPr sz="1000"/>
+              <a:defRPr sz="999"/>
             </a:lvl8pPr>
-            <a:lvl9pPr marL="3657600" indent="0">
+            <a:lvl9pPr marL="3657375" indent="0">
               <a:buNone/>
-              <a:defRPr sz="1000"/>
+              <a:defRPr sz="999"/>
             </a:lvl9pPr>
           </a:lstStyle>
           <a:p>
@@ -2383,7 +2384,7 @@
           <a:p>
             <a:fld id="{DC3DD596-B551-4104-AF86-405EBC7207B6}" type="datetimeFigureOut">
               <a:rPr lang="en-US" smtClean="0"/>
-              <a:t>6/26/2026</a:t>
+              <a:t>7/31/2026</a:t>
             </a:fld>
             <a:endParaRPr lang="en-US"/>
           </a:p>
@@ -2491,7 +2492,7 @@
         </p:nvSpPr>
         <p:spPr>
           <a:xfrm>
-            <a:off x="839788" y="457200"/>
+            <a:off x="839789" y="457200"/>
             <a:ext cx="3932237" cy="1600200"/>
           </a:xfrm>
         </p:spPr>
@@ -2528,7 +2529,7 @@
         </p:nvSpPr>
         <p:spPr>
           <a:xfrm>
-            <a:off x="5183188" y="987425"/>
+            <a:off x="5183188" y="987427"/>
             <a:ext cx="6172200" cy="4873625"/>
           </a:xfrm>
         </p:spPr>
@@ -2539,35 +2540,35 @@
               <a:buNone/>
               <a:defRPr sz="3200"/>
             </a:lvl1pPr>
-            <a:lvl2pPr marL="457200" indent="0">
+            <a:lvl2pPr marL="457172" indent="0">
               <a:buNone/>
               <a:defRPr sz="2800"/>
             </a:lvl2pPr>
-            <a:lvl3pPr marL="914400" indent="0">
+            <a:lvl3pPr marL="914344" indent="0">
               <a:buNone/>
               <a:defRPr sz="2400"/>
             </a:lvl3pPr>
-            <a:lvl4pPr marL="1371600" indent="0">
+            <a:lvl4pPr marL="1371516" indent="0">
               <a:buNone/>
               <a:defRPr sz="2000"/>
             </a:lvl4pPr>
-            <a:lvl5pPr marL="1828800" indent="0">
+            <a:lvl5pPr marL="1828687" indent="0">
               <a:buNone/>
               <a:defRPr sz="2000"/>
             </a:lvl5pPr>
-            <a:lvl6pPr marL="2286000" indent="0">
+            <a:lvl6pPr marL="2285859" indent="0">
               <a:buNone/>
               <a:defRPr sz="2000"/>
             </a:lvl6pPr>
-            <a:lvl7pPr marL="2743200" indent="0">
+            <a:lvl7pPr marL="2743032" indent="0">
               <a:buNone/>
               <a:defRPr sz="2000"/>
             </a:lvl7pPr>
-            <a:lvl8pPr marL="3200400" indent="0">
+            <a:lvl8pPr marL="3200203" indent="0">
               <a:buNone/>
               <a:defRPr sz="2000"/>
             </a:lvl8pPr>
-            <a:lvl9pPr marL="3657600" indent="0">
+            <a:lvl9pPr marL="3657375" indent="0">
               <a:buNone/>
               <a:defRPr sz="2000"/>
             </a:lvl9pPr>
@@ -2595,7 +2596,7 @@
         </p:nvSpPr>
         <p:spPr>
           <a:xfrm>
-            <a:off x="839788" y="2057400"/>
+            <a:off x="839789" y="2057400"/>
             <a:ext cx="3932237" cy="3811588"/>
           </a:xfrm>
         </p:spPr>
@@ -2606,37 +2607,37 @@
               <a:buNone/>
               <a:defRPr sz="1600"/>
             </a:lvl1pPr>
-            <a:lvl2pPr marL="457200" indent="0">
+            <a:lvl2pPr marL="457172" indent="0">
               <a:buNone/>
-              <a:defRPr sz="1400"/>
+              <a:defRPr sz="1399"/>
             </a:lvl2pPr>
-            <a:lvl3pPr marL="914400" indent="0">
+            <a:lvl3pPr marL="914344" indent="0">
               <a:buNone/>
               <a:defRPr sz="1200"/>
             </a:lvl3pPr>
-            <a:lvl4pPr marL="1371600" indent="0">
+            <a:lvl4pPr marL="1371516" indent="0">
               <a:buNone/>
-              <a:defRPr sz="1000"/>
+              <a:defRPr sz="999"/>
             </a:lvl4pPr>
-            <a:lvl5pPr marL="1828800" indent="0">
+            <a:lvl5pPr marL="1828687" indent="0">
               <a:buNone/>
-              <a:defRPr sz="1000"/>
+              <a:defRPr sz="999"/>
             </a:lvl5pPr>
-            <a:lvl6pPr marL="2286000" indent="0">
+            <a:lvl6pPr marL="2285859" indent="0">
               <a:buNone/>
-              <a:defRPr sz="1000"/>
+              <a:defRPr sz="999"/>
             </a:lvl6pPr>
-            <a:lvl7pPr marL="2743200" indent="0">
+            <a:lvl7pPr marL="2743032" indent="0">
               <a:buNone/>
-              <a:defRPr sz="1000"/>
+              <a:defRPr sz="999"/>
             </a:lvl7pPr>
-            <a:lvl8pPr marL="3200400" indent="0">
+            <a:lvl8pPr marL="3200203" indent="0">
               <a:buNone/>
-              <a:defRPr sz="1000"/>
+              <a:defRPr sz="999"/>
             </a:lvl8pPr>
-            <a:lvl9pPr marL="3657600" indent="0">
+            <a:lvl9pPr marL="3657375" indent="0">
               <a:buNone/>
-              <a:defRPr sz="1000"/>
+              <a:defRPr sz="999"/>
             </a:lvl9pPr>
           </a:lstStyle>
           <a:p>
@@ -2671,7 +2672,7 @@
           <a:p>
             <a:fld id="{DC3DD596-B551-4104-AF86-405EBC7207B6}" type="datetimeFigureOut">
               <a:rPr lang="en-US" smtClean="0"/>
-              <a:t>6/26/2026</a:t>
+              <a:t>7/31/2026</a:t>
             </a:fld>
             <a:endParaRPr lang="en-US"/>
           </a:p>
@@ -2784,7 +2785,7 @@
         </p:nvSpPr>
         <p:spPr>
           <a:xfrm>
-            <a:off x="838200" y="365125"/>
+            <a:off x="838201" y="365127"/>
             <a:ext cx="10515600" cy="1325563"/>
           </a:xfrm>
           <a:prstGeom prst="rect">
@@ -2822,7 +2823,7 @@
         </p:nvSpPr>
         <p:spPr>
           <a:xfrm>
-            <a:off x="838200" y="1825625"/>
+            <a:off x="838201" y="1825625"/>
             <a:ext cx="10515600" cy="4351338"/>
           </a:xfrm>
           <a:prstGeom prst="rect">
@@ -2889,7 +2890,7 @@
         </p:nvSpPr>
         <p:spPr>
           <a:xfrm>
-            <a:off x="838200" y="6356350"/>
+            <a:off x="838201" y="6356352"/>
             <a:ext cx="2743200" cy="365125"/>
           </a:xfrm>
           <a:prstGeom prst="rect">
@@ -2912,7 +2913,7 @@
           <a:p>
             <a:fld id="{DC3DD596-B551-4104-AF86-405EBC7207B6}" type="datetimeFigureOut">
               <a:rPr lang="en-US" smtClean="0"/>
-              <a:t>6/26/2026</a:t>
+              <a:t>7/31/2026</a:t>
             </a:fld>
             <a:endParaRPr lang="en-US"/>
           </a:p>
@@ -2936,7 +2937,7 @@
         </p:nvSpPr>
         <p:spPr>
           <a:xfrm>
-            <a:off x="4038600" y="6356350"/>
+            <a:off x="4038601" y="6356352"/>
             <a:ext cx="4114800" cy="365125"/>
           </a:xfrm>
           <a:prstGeom prst="rect">
@@ -2979,7 +2980,7 @@
         </p:nvSpPr>
         <p:spPr>
           <a:xfrm>
-            <a:off x="8610600" y="6356350"/>
+            <a:off x="8610601" y="6356352"/>
             <a:ext cx="2743200" cy="365125"/>
           </a:xfrm>
           <a:prstGeom prst="rect">
@@ -3031,7 +3032,7 @@
   </p:sldLayoutIdLst>
   <p:txStyles>
     <p:titleStyle>
-      <a:lvl1pPr algn="l" defTabSz="914400" rtl="0" eaLnBrk="1" latinLnBrk="0" hangingPunct="1">
+      <a:lvl1pPr algn="l" defTabSz="914344" rtl="0" eaLnBrk="1" latinLnBrk="0" hangingPunct="1">
         <a:lnSpc>
           <a:spcPct val="90000"/>
         </a:lnSpc>
@@ -3050,12 +3051,12 @@
       </a:lvl1pPr>
     </p:titleStyle>
     <p:bodyStyle>
-      <a:lvl1pPr marL="228600" indent="-228600" algn="l" defTabSz="914400" rtl="0" eaLnBrk="1" latinLnBrk="0" hangingPunct="1">
+      <a:lvl1pPr marL="228586" indent="-228586" algn="l" defTabSz="914344" rtl="0" eaLnBrk="1" latinLnBrk="0" hangingPunct="1">
         <a:lnSpc>
           <a:spcPct val="90000"/>
         </a:lnSpc>
         <a:spcBef>
-          <a:spcPts val="1000"/>
+          <a:spcPts val="999"/>
         </a:spcBef>
         <a:buFont typeface="Arial" panose="020B0604020202020204" pitchFamily="34" charset="0"/>
         <a:buChar char="•"/>
@@ -3068,7 +3069,7 @@
           <a:cs typeface="+mn-cs"/>
         </a:defRPr>
       </a:lvl1pPr>
-      <a:lvl2pPr marL="685800" indent="-228600" algn="l" defTabSz="914400" rtl="0" eaLnBrk="1" latinLnBrk="0" hangingPunct="1">
+      <a:lvl2pPr marL="685758" indent="-228586" algn="l" defTabSz="914344" rtl="0" eaLnBrk="1" latinLnBrk="0" hangingPunct="1">
         <a:lnSpc>
           <a:spcPct val="90000"/>
         </a:lnSpc>
@@ -3086,7 +3087,7 @@
           <a:cs typeface="+mn-cs"/>
         </a:defRPr>
       </a:lvl2pPr>
-      <a:lvl3pPr marL="1143000" indent="-228600" algn="l" defTabSz="914400" rtl="0" eaLnBrk="1" latinLnBrk="0" hangingPunct="1">
+      <a:lvl3pPr marL="1142930" indent="-228586" algn="l" defTabSz="914344" rtl="0" eaLnBrk="1" latinLnBrk="0" hangingPunct="1">
         <a:lnSpc>
           <a:spcPct val="90000"/>
         </a:lnSpc>
@@ -3104,7 +3105,7 @@
           <a:cs typeface="+mn-cs"/>
         </a:defRPr>
       </a:lvl3pPr>
-      <a:lvl4pPr marL="1600200" indent="-228600" algn="l" defTabSz="914400" rtl="0" eaLnBrk="1" latinLnBrk="0" hangingPunct="1">
+      <a:lvl4pPr marL="1600101" indent="-228586" algn="l" defTabSz="914344" rtl="0" eaLnBrk="1" latinLnBrk="0" hangingPunct="1">
         <a:lnSpc>
           <a:spcPct val="90000"/>
         </a:lnSpc>
@@ -3113,7 +3114,7 @@
         </a:spcBef>
         <a:buFont typeface="Arial" panose="020B0604020202020204" pitchFamily="34" charset="0"/>
         <a:buChar char="•"/>
-        <a:defRPr sz="1800" kern="1200">
+        <a:defRPr sz="1799" kern="1200">
           <a:solidFill>
             <a:schemeClr val="tx1"/>
           </a:solidFill>
@@ -3122,7 +3123,7 @@
           <a:cs typeface="+mn-cs"/>
         </a:defRPr>
       </a:lvl4pPr>
-      <a:lvl5pPr marL="2057400" indent="-228600" algn="l" defTabSz="914400" rtl="0" eaLnBrk="1" latinLnBrk="0" hangingPunct="1">
+      <a:lvl5pPr marL="2057274" indent="-228586" algn="l" defTabSz="914344" rtl="0" eaLnBrk="1" latinLnBrk="0" hangingPunct="1">
         <a:lnSpc>
           <a:spcPct val="90000"/>
         </a:lnSpc>
@@ -3131,7 +3132,7 @@
         </a:spcBef>
         <a:buFont typeface="Arial" panose="020B0604020202020204" pitchFamily="34" charset="0"/>
         <a:buChar char="•"/>
-        <a:defRPr sz="1800" kern="1200">
+        <a:defRPr sz="1799" kern="1200">
           <a:solidFill>
             <a:schemeClr val="tx1"/>
           </a:solidFill>
@@ -3140,7 +3141,7 @@
           <a:cs typeface="+mn-cs"/>
         </a:defRPr>
       </a:lvl5pPr>
-      <a:lvl6pPr marL="2514600" indent="-228600" algn="l" defTabSz="914400" rtl="0" eaLnBrk="1" latinLnBrk="0" hangingPunct="1">
+      <a:lvl6pPr marL="2514445" indent="-228586" algn="l" defTabSz="914344" rtl="0" eaLnBrk="1" latinLnBrk="0" hangingPunct="1">
         <a:lnSpc>
           <a:spcPct val="90000"/>
         </a:lnSpc>
@@ -3149,7 +3150,7 @@
         </a:spcBef>
         <a:buFont typeface="Arial" panose="020B0604020202020204" pitchFamily="34" charset="0"/>
         <a:buChar char="•"/>
-        <a:defRPr sz="1800" kern="1200">
+        <a:defRPr sz="1799" kern="1200">
           <a:solidFill>
             <a:schemeClr val="tx1"/>
           </a:solidFill>
@@ -3158,7 +3159,7 @@
           <a:cs typeface="+mn-cs"/>
         </a:defRPr>
       </a:lvl6pPr>
-      <a:lvl7pPr marL="2971800" indent="-228600" algn="l" defTabSz="914400" rtl="0" eaLnBrk="1" latinLnBrk="0" hangingPunct="1">
+      <a:lvl7pPr marL="2971617" indent="-228586" algn="l" defTabSz="914344" rtl="0" eaLnBrk="1" latinLnBrk="0" hangingPunct="1">
         <a:lnSpc>
           <a:spcPct val="90000"/>
         </a:lnSpc>
@@ -3167,7 +3168,7 @@
         </a:spcBef>
         <a:buFont typeface="Arial" panose="020B0604020202020204" pitchFamily="34" charset="0"/>
         <a:buChar char="•"/>
-        <a:defRPr sz="1800" kern="1200">
+        <a:defRPr sz="1799" kern="1200">
           <a:solidFill>
             <a:schemeClr val="tx1"/>
           </a:solidFill>
@@ -3176,7 +3177,7 @@
           <a:cs typeface="+mn-cs"/>
         </a:defRPr>
       </a:lvl7pPr>
-      <a:lvl8pPr marL="3429000" indent="-228600" algn="l" defTabSz="914400" rtl="0" eaLnBrk="1" latinLnBrk="0" hangingPunct="1">
+      <a:lvl8pPr marL="3428790" indent="-228586" algn="l" defTabSz="914344" rtl="0" eaLnBrk="1" latinLnBrk="0" hangingPunct="1">
         <a:lnSpc>
           <a:spcPct val="90000"/>
         </a:lnSpc>
@@ -3185,7 +3186,7 @@
         </a:spcBef>
         <a:buFont typeface="Arial" panose="020B0604020202020204" pitchFamily="34" charset="0"/>
         <a:buChar char="•"/>
-        <a:defRPr sz="1800" kern="1200">
+        <a:defRPr sz="1799" kern="1200">
           <a:solidFill>
             <a:schemeClr val="tx1"/>
           </a:solidFill>
@@ -3194,7 +3195,7 @@
           <a:cs typeface="+mn-cs"/>
         </a:defRPr>
       </a:lvl8pPr>
-      <a:lvl9pPr marL="3886200" indent="-228600" algn="l" defTabSz="914400" rtl="0" eaLnBrk="1" latinLnBrk="0" hangingPunct="1">
+      <a:lvl9pPr marL="3885961" indent="-228586" algn="l" defTabSz="914344" rtl="0" eaLnBrk="1" latinLnBrk="0" hangingPunct="1">
         <a:lnSpc>
           <a:spcPct val="90000"/>
         </a:lnSpc>
@@ -3203,7 +3204,7 @@
         </a:spcBef>
         <a:buFont typeface="Arial" panose="020B0604020202020204" pitchFamily="34" charset="0"/>
         <a:buChar char="•"/>
-        <a:defRPr sz="1800" kern="1200">
+        <a:defRPr sz="1799" kern="1200">
           <a:solidFill>
             <a:schemeClr val="tx1"/>
           </a:solidFill>
@@ -3217,8 +3218,8 @@
       <a:defPPr>
         <a:defRPr lang="en-US"/>
       </a:defPPr>
-      <a:lvl1pPr marL="0" algn="l" defTabSz="914400" rtl="0" eaLnBrk="1" latinLnBrk="0" hangingPunct="1">
-        <a:defRPr sz="1800" kern="1200">
+      <a:lvl1pPr marL="0" algn="l" defTabSz="914344" rtl="0" eaLnBrk="1" latinLnBrk="0" hangingPunct="1">
+        <a:defRPr sz="1799" kern="1200">
           <a:solidFill>
             <a:schemeClr val="tx1"/>
           </a:solidFill>
@@ -3227,8 +3228,8 @@
           <a:cs typeface="+mn-cs"/>
         </a:defRPr>
       </a:lvl1pPr>
-      <a:lvl2pPr marL="457200" algn="l" defTabSz="914400" rtl="0" eaLnBrk="1" latinLnBrk="0" hangingPunct="1">
-        <a:defRPr sz="1800" kern="1200">
+      <a:lvl2pPr marL="457172" algn="l" defTabSz="914344" rtl="0" eaLnBrk="1" latinLnBrk="0" hangingPunct="1">
+        <a:defRPr sz="1799" kern="1200">
           <a:solidFill>
             <a:schemeClr val="tx1"/>
           </a:solidFill>
@@ -3237,8 +3238,8 @@
           <a:cs typeface="+mn-cs"/>
         </a:defRPr>
       </a:lvl2pPr>
-      <a:lvl3pPr marL="914400" algn="l" defTabSz="914400" rtl="0" eaLnBrk="1" latinLnBrk="0" hangingPunct="1">
-        <a:defRPr sz="1800" kern="1200">
+      <a:lvl3pPr marL="914344" algn="l" defTabSz="914344" rtl="0" eaLnBrk="1" latinLnBrk="0" hangingPunct="1">
+        <a:defRPr sz="1799" kern="1200">
           <a:solidFill>
             <a:schemeClr val="tx1"/>
           </a:solidFill>
@@ -3247,8 +3248,8 @@
           <a:cs typeface="+mn-cs"/>
         </a:defRPr>
       </a:lvl3pPr>
-      <a:lvl4pPr marL="1371600" algn="l" defTabSz="914400" rtl="0" eaLnBrk="1" latinLnBrk="0" hangingPunct="1">
-        <a:defRPr sz="1800" kern="1200">
+      <a:lvl4pPr marL="1371516" algn="l" defTabSz="914344" rtl="0" eaLnBrk="1" latinLnBrk="0" hangingPunct="1">
+        <a:defRPr sz="1799" kern="1200">
           <a:solidFill>
             <a:schemeClr val="tx1"/>
           </a:solidFill>
@@ -3257,8 +3258,8 @@
           <a:cs typeface="+mn-cs"/>
         </a:defRPr>
       </a:lvl4pPr>
-      <a:lvl5pPr marL="1828800" algn="l" defTabSz="914400" rtl="0" eaLnBrk="1" latinLnBrk="0" hangingPunct="1">
-        <a:defRPr sz="1800" kern="1200">
+      <a:lvl5pPr marL="1828687" algn="l" defTabSz="914344" rtl="0" eaLnBrk="1" latinLnBrk="0" hangingPunct="1">
+        <a:defRPr sz="1799" kern="1200">
           <a:solidFill>
             <a:schemeClr val="tx1"/>
           </a:solidFill>
@@ -3267,8 +3268,8 @@
           <a:cs typeface="+mn-cs"/>
         </a:defRPr>
       </a:lvl5pPr>
-      <a:lvl6pPr marL="2286000" algn="l" defTabSz="914400" rtl="0" eaLnBrk="1" latinLnBrk="0" hangingPunct="1">
-        <a:defRPr sz="1800" kern="1200">
+      <a:lvl6pPr marL="2285859" algn="l" defTabSz="914344" rtl="0" eaLnBrk="1" latinLnBrk="0" hangingPunct="1">
+        <a:defRPr sz="1799" kern="1200">
           <a:solidFill>
             <a:schemeClr val="tx1"/>
           </a:solidFill>
@@ -3277,8 +3278,8 @@
           <a:cs typeface="+mn-cs"/>
         </a:defRPr>
       </a:lvl6pPr>
-      <a:lvl7pPr marL="2743200" algn="l" defTabSz="914400" rtl="0" eaLnBrk="1" latinLnBrk="0" hangingPunct="1">
-        <a:defRPr sz="1800" kern="1200">
+      <a:lvl7pPr marL="2743032" algn="l" defTabSz="914344" rtl="0" eaLnBrk="1" latinLnBrk="0" hangingPunct="1">
+        <a:defRPr sz="1799" kern="1200">
           <a:solidFill>
             <a:schemeClr val="tx1"/>
           </a:solidFill>
@@ -3287,8 +3288,8 @@
           <a:cs typeface="+mn-cs"/>
         </a:defRPr>
       </a:lvl7pPr>
-      <a:lvl8pPr marL="3200400" algn="l" defTabSz="914400" rtl="0" eaLnBrk="1" latinLnBrk="0" hangingPunct="1">
-        <a:defRPr sz="1800" kern="1200">
+      <a:lvl8pPr marL="3200203" algn="l" defTabSz="914344" rtl="0" eaLnBrk="1" latinLnBrk="0" hangingPunct="1">
+        <a:defRPr sz="1799" kern="1200">
           <a:solidFill>
             <a:schemeClr val="tx1"/>
           </a:solidFill>
@@ -3297,8 +3298,8 @@
           <a:cs typeface="+mn-cs"/>
         </a:defRPr>
       </a:lvl8pPr>
-      <a:lvl9pPr marL="3657600" algn="l" defTabSz="914400" rtl="0" eaLnBrk="1" latinLnBrk="0" hangingPunct="1">
-        <a:defRPr sz="1800" kern="1200">
+      <a:lvl9pPr marL="3657375" algn="l" defTabSz="914344" rtl="0" eaLnBrk="1" latinLnBrk="0" hangingPunct="1">
+        <a:defRPr sz="1799" kern="1200">
           <a:solidFill>
             <a:schemeClr val="tx1"/>
           </a:solidFill>
@@ -3371,10 +3372,10 @@
         </p:nvGrpSpPr>
         <p:grpSpPr>
           <a:xfrm>
-            <a:off x="6867525" y="1456549"/>
-            <a:ext cx="5219700" cy="4610216"/>
+            <a:off x="6867528" y="1456550"/>
+            <a:ext cx="5219698" cy="4610215"/>
             <a:chOff x="6867525" y="1456549"/>
-            <a:chExt cx="5219700" cy="4610216"/>
+            <a:chExt cx="5219700" cy="4610217"/>
           </a:xfrm>
         </p:grpSpPr>
         <p:sp>
@@ -3429,7 +3430,7 @@
             <a:lstStyle/>
             <a:p>
               <a:pPr algn="ctr"/>
-              <a:endParaRPr lang="en-US"/>
+              <a:endParaRPr lang="en-US" sz="1799"/>
             </a:p>
           </p:txBody>
         </p:sp>
@@ -3485,7 +3486,7 @@
             <a:lstStyle/>
             <a:p>
               <a:pPr algn="ctr"/>
-              <a:endParaRPr lang="en-US"/>
+              <a:endParaRPr lang="en-US" sz="1799"/>
             </a:p>
           </p:txBody>
         </p:sp>
@@ -3575,7 +3576,7 @@
             <a:lstStyle/>
             <a:p>
               <a:pPr algn="ctr"/>
-              <a:endParaRPr lang="en-US"/>
+              <a:endParaRPr lang="en-US" sz="1799"/>
             </a:p>
           </p:txBody>
         </p:sp>
@@ -3593,8 +3594,8 @@
           </p:nvSpPr>
           <p:spPr>
             <a:xfrm>
-              <a:off x="7489032" y="1456549"/>
-              <a:ext cx="1100130" cy="276999"/>
+              <a:off x="7489031" y="1456549"/>
+              <a:ext cx="1100131" cy="276999"/>
             </a:xfrm>
             <a:prstGeom prst="rect">
               <a:avLst/>
@@ -3702,7 +3703,7 @@
             <a:lstStyle/>
             <a:p>
               <a:pPr algn="ctr"/>
-              <a:endParaRPr lang="en-US"/>
+              <a:endParaRPr lang="en-US" sz="1799"/>
             </a:p>
           </p:txBody>
         </p:sp>
@@ -3762,8 +3763,8 @@
           </p:nvSpPr>
           <p:spPr>
             <a:xfrm>
-              <a:off x="9020175" y="2021132"/>
-              <a:ext cx="1100130" cy="276999"/>
+              <a:off x="9020176" y="2021132"/>
+              <a:ext cx="1100131" cy="276999"/>
             </a:xfrm>
             <a:prstGeom prst="rect">
               <a:avLst/>
@@ -3840,7 +3841,7 @@
           </p:nvSpPr>
           <p:spPr>
             <a:xfrm>
-              <a:off x="9036260" y="4936223"/>
+              <a:off x="9036262" y="4936225"/>
               <a:ext cx="645309" cy="276999"/>
             </a:xfrm>
             <a:prstGeom prst="rect">
@@ -3918,7 +3919,7 @@
           </p:nvSpPr>
           <p:spPr>
             <a:xfrm>
-              <a:off x="9214864" y="5220741"/>
+              <a:off x="9214864" y="5220744"/>
               <a:ext cx="645309" cy="276999"/>
             </a:xfrm>
             <a:prstGeom prst="rect">
@@ -3996,8 +3997,8 @@
           </p:nvSpPr>
           <p:spPr>
             <a:xfrm>
-              <a:off x="9048757" y="5789766"/>
-              <a:ext cx="1100130" cy="276999"/>
+              <a:off x="9048758" y="5789767"/>
+              <a:ext cx="1100131" cy="276999"/>
             </a:xfrm>
             <a:prstGeom prst="rect">
               <a:avLst/>
@@ -4034,9 +4035,9 @@
         <p:grpSpPr>
           <a:xfrm>
             <a:off x="-202404" y="1508992"/>
-            <a:ext cx="7714198" cy="4782729"/>
+            <a:ext cx="7714198" cy="4596914"/>
             <a:chOff x="-202404" y="1508992"/>
-            <a:chExt cx="7714198" cy="4782729"/>
+            <a:chExt cx="7714198" cy="4794645"/>
           </a:xfrm>
         </p:grpSpPr>
         <p:sp>
@@ -4053,8 +4054,8 @@
           </p:nvSpPr>
           <p:spPr>
             <a:xfrm>
-              <a:off x="6411664" y="4095694"/>
-              <a:ext cx="1100130" cy="276999"/>
+              <a:off x="6411663" y="4095694"/>
+              <a:ext cx="1100131" cy="288914"/>
             </a:xfrm>
             <a:prstGeom prst="rect">
               <a:avLst/>
@@ -4117,7 +4118,7 @@
             <a:p>
               <a:pPr algn="ctr"/>
               <a:r>
-                <a:rPr lang="en-US" dirty="0"/>
+                <a:rPr lang="en-US" sz="1799" dirty="0"/>
                 <a:t>DAQ</a:t>
               </a:r>
             </a:p>
@@ -4175,7 +4176,7 @@
             <a:lstStyle/>
             <a:p>
               <a:pPr algn="ctr"/>
-              <a:endParaRPr lang="en-US"/>
+              <a:endParaRPr lang="en-US" sz="1799"/>
             </a:p>
           </p:txBody>
         </p:sp>
@@ -4231,7 +4232,7 @@
             <a:lstStyle/>
             <a:p>
               <a:pPr algn="ctr"/>
-              <a:endParaRPr lang="en-US"/>
+              <a:endParaRPr lang="en-US" sz="1799"/>
             </a:p>
           </p:txBody>
         </p:sp>
@@ -4285,7 +4286,7 @@
             <a:lstStyle/>
             <a:p>
               <a:pPr algn="ctr"/>
-              <a:endParaRPr lang="en-US"/>
+              <a:endParaRPr lang="en-US" sz="1799"/>
             </a:p>
           </p:txBody>
         </p:sp>
@@ -4378,7 +4379,7 @@
             <a:lstStyle/>
             <a:p>
               <a:pPr algn="ctr"/>
-              <a:endParaRPr lang="en-US"/>
+              <a:endParaRPr lang="en-US" sz="1799"/>
             </a:p>
           </p:txBody>
         </p:sp>
@@ -4424,7 +4425,7 @@
             <a:lstStyle/>
             <a:p>
               <a:pPr algn="ctr"/>
-              <a:endParaRPr lang="en-US">
+              <a:endParaRPr lang="en-US" sz="1799">
                 <a:solidFill>
                   <a:schemeClr val="tx1"/>
                 </a:solidFill>
@@ -4474,7 +4475,7 @@
             <a:lstStyle/>
             <a:p>
               <a:pPr algn="ctr"/>
-              <a:endParaRPr lang="en-US">
+              <a:endParaRPr lang="en-US" sz="1799">
                 <a:solidFill>
                   <a:schemeClr val="tx1"/>
                 </a:solidFill>
@@ -4529,7 +4530,7 @@
             <a:lstStyle/>
             <a:p>
               <a:pPr algn="ctr"/>
-              <a:endParaRPr lang="en-US"/>
+              <a:endParaRPr lang="en-US" sz="1799"/>
             </a:p>
           </p:txBody>
         </p:sp>
@@ -4589,8 +4590,8 @@
           </p:nvSpPr>
           <p:spPr>
             <a:xfrm>
-              <a:off x="2350286" y="3072392"/>
-              <a:ext cx="1100130" cy="276999"/>
+              <a:off x="2350287" y="3072391"/>
+              <a:ext cx="1100131" cy="288914"/>
             </a:xfrm>
             <a:prstGeom prst="rect">
               <a:avLst/>
@@ -4748,8 +4749,8 @@
           </p:nvSpPr>
           <p:spPr>
             <a:xfrm>
-              <a:off x="2793210" y="6014722"/>
-              <a:ext cx="1100130" cy="276999"/>
+              <a:off x="2793210" y="6014723"/>
+              <a:ext cx="1100131" cy="288914"/>
             </a:xfrm>
             <a:prstGeom prst="rect">
               <a:avLst/>
@@ -4826,8 +4827,8 @@
           </p:nvSpPr>
           <p:spPr>
             <a:xfrm>
-              <a:off x="3012281" y="4963549"/>
-              <a:ext cx="1100130" cy="276999"/>
+              <a:off x="3012282" y="4963549"/>
+              <a:ext cx="1100131" cy="288914"/>
             </a:xfrm>
             <a:prstGeom prst="rect">
               <a:avLst/>
@@ -4863,7 +4864,7 @@
           <p:spPr>
             <a:xfrm>
               <a:off x="5379247" y="4794424"/>
-              <a:ext cx="1100130" cy="276999"/>
+              <a:ext cx="1100131" cy="288914"/>
             </a:xfrm>
             <a:prstGeom prst="rect">
               <a:avLst/>
@@ -4898,8 +4899,8 @@
           </p:nvSpPr>
           <p:spPr>
             <a:xfrm>
-              <a:off x="5069682" y="2089578"/>
-              <a:ext cx="1100130" cy="276999"/>
+              <a:off x="5069682" y="2089579"/>
+              <a:ext cx="1100131" cy="288914"/>
             </a:xfrm>
             <a:prstGeom prst="rect">
               <a:avLst/>
@@ -4935,7 +4936,7 @@
           <p:spPr>
             <a:xfrm>
               <a:off x="5069682" y="1508992"/>
-              <a:ext cx="1100130" cy="276999"/>
+              <a:ext cx="1100131" cy="288914"/>
             </a:xfrm>
             <a:prstGeom prst="rect">
               <a:avLst/>
@@ -5220,8 +5221,8 @@
           </p:nvSpPr>
           <p:spPr>
             <a:xfrm>
-              <a:off x="-202404" y="4692034"/>
-              <a:ext cx="1100130" cy="276999"/>
+              <a:off x="-202404" y="4692032"/>
+              <a:ext cx="1100131" cy="288914"/>
             </a:xfrm>
             <a:prstGeom prst="rect">
               <a:avLst/>
@@ -5255,8 +5256,8 @@
           </p:nvSpPr>
           <p:spPr>
             <a:xfrm>
-              <a:off x="-180967" y="5138613"/>
-              <a:ext cx="1100130" cy="276999"/>
+              <a:off x="-180967" y="5138610"/>
+              <a:ext cx="1100131" cy="288914"/>
             </a:xfrm>
             <a:prstGeom prst="rect">
               <a:avLst/>
@@ -5374,8 +5375,8 @@
           </p:nvSpPr>
           <p:spPr>
             <a:xfrm>
-              <a:off x="2805112" y="5604146"/>
-              <a:ext cx="1100130" cy="276999"/>
+              <a:off x="2805111" y="5604146"/>
+              <a:ext cx="1100131" cy="288914"/>
             </a:xfrm>
             <a:prstGeom prst="rect">
               <a:avLst/>
@@ -5410,8 +5411,8 @@
           </p:nvSpPr>
           <p:spPr>
             <a:xfrm>
-              <a:off x="4071943" y="5261510"/>
-              <a:ext cx="1100130" cy="276999"/>
+              <a:off x="4071943" y="5261509"/>
+              <a:ext cx="1100131" cy="288914"/>
             </a:xfrm>
             <a:prstGeom prst="rect">
               <a:avLst/>
@@ -5474,7 +5475,7 @@
             <a:lstStyle/>
             <a:p>
               <a:pPr algn="ctr"/>
-              <a:endParaRPr lang="en-US"/>
+              <a:endParaRPr lang="en-US" sz="1799"/>
             </a:p>
           </p:txBody>
         </p:sp>
@@ -5520,7 +5521,7 @@
             <a:lstStyle/>
             <a:p>
               <a:pPr algn="ctr"/>
-              <a:endParaRPr lang="en-US"/>
+              <a:endParaRPr lang="en-US" sz="1799"/>
             </a:p>
           </p:txBody>
         </p:sp>
@@ -5539,7 +5540,7 @@
           <p:spPr>
             <a:xfrm>
               <a:off x="3940978" y="3494512"/>
-              <a:ext cx="1554945" cy="276999"/>
+              <a:ext cx="1554947" cy="288914"/>
             </a:xfrm>
             <a:prstGeom prst="rect">
               <a:avLst/>
@@ -5574,8 +5575,8 @@
           </p:nvSpPr>
           <p:spPr>
             <a:xfrm>
-              <a:off x="1190624" y="3509464"/>
-              <a:ext cx="1554945" cy="276999"/>
+              <a:off x="1190623" y="3509464"/>
+              <a:ext cx="1554947" cy="288914"/>
             </a:xfrm>
             <a:prstGeom prst="rect">
               <a:avLst/>
@@ -5638,7 +5639,7 @@
             <a:lstStyle/>
             <a:p>
               <a:pPr algn="ctr"/>
-              <a:endParaRPr lang="en-US"/>
+              <a:endParaRPr lang="en-US" sz="1799"/>
             </a:p>
           </p:txBody>
         </p:sp>
@@ -5684,7 +5685,7 @@
             <a:lstStyle/>
             <a:p>
               <a:pPr algn="ctr"/>
-              <a:endParaRPr lang="en-US"/>
+              <a:endParaRPr lang="en-US" sz="1799"/>
             </a:p>
           </p:txBody>
         </p:sp>
@@ -5744,8 +5745,8 @@
           </p:nvSpPr>
           <p:spPr>
             <a:xfrm>
-              <a:off x="2246708" y="4647608"/>
-              <a:ext cx="2117505" cy="276999"/>
+              <a:off x="2246708" y="4647609"/>
+              <a:ext cx="2117504" cy="288914"/>
             </a:xfrm>
             <a:prstGeom prst="rect">
               <a:avLst/>
@@ -5863,8 +5864,8 @@
           </p:nvSpPr>
           <p:spPr>
             <a:xfrm>
-              <a:off x="1847850" y="2161457"/>
-              <a:ext cx="945359" cy="276999"/>
+              <a:off x="1847850" y="2161456"/>
+              <a:ext cx="945361" cy="288914"/>
             </a:xfrm>
             <a:prstGeom prst="rect">
               <a:avLst/>
@@ -5981,8 +5982,8 @@
           </p:nvSpPr>
           <p:spPr>
             <a:xfrm>
-              <a:off x="5960" y="3376880"/>
-              <a:ext cx="1100130" cy="276999"/>
+              <a:off x="5959" y="3376879"/>
+              <a:ext cx="1100131" cy="288914"/>
             </a:xfrm>
             <a:prstGeom prst="rect">
               <a:avLst/>
@@ -6163,8 +6164,8 @@
         </p:nvSpPr>
         <p:spPr>
           <a:xfrm>
-            <a:off x="2180530" y="2375132"/>
-            <a:ext cx="1100130" cy="369332"/>
+            <a:off x="2180532" y="2375135"/>
+            <a:ext cx="1100131" cy="369204"/>
           </a:xfrm>
           <a:prstGeom prst="rect">
             <a:avLst/>
@@ -6178,7 +6179,7 @@
           <a:lstStyle/>
           <a:p>
             <a:r>
-              <a:rPr lang="en-US" b="1" dirty="0"/>
+              <a:rPr lang="en-US" sz="1799" b="1" dirty="0"/>
               <a:t>Top view</a:t>
             </a:r>
           </a:p>
@@ -6198,8 +6199,8 @@
         </p:nvGrpSpPr>
         <p:grpSpPr>
           <a:xfrm>
-            <a:off x="126726" y="2872561"/>
-            <a:ext cx="5032937" cy="2571750"/>
+            <a:off x="126725" y="2872559"/>
+            <a:ext cx="5032939" cy="2571750"/>
             <a:chOff x="635838" y="2266950"/>
             <a:chExt cx="5032937" cy="2571750"/>
           </a:xfrm>
@@ -6256,7 +6257,7 @@
             <a:lstStyle/>
             <a:p>
               <a:pPr algn="ctr"/>
-              <a:endParaRPr lang="en-US"/>
+              <a:endParaRPr lang="en-US" sz="1799"/>
             </a:p>
           </p:txBody>
         </p:sp>
@@ -6312,7 +6313,7 @@
             <a:lstStyle/>
             <a:p>
               <a:pPr algn="ctr"/>
-              <a:endParaRPr lang="en-US"/>
+              <a:endParaRPr lang="en-US" sz="1799"/>
             </a:p>
           </p:txBody>
         </p:sp>
@@ -6368,7 +6369,7 @@
             <a:lstStyle/>
             <a:p>
               <a:pPr algn="ctr"/>
-              <a:endParaRPr lang="en-US"/>
+              <a:endParaRPr lang="en-US" sz="1799"/>
             </a:p>
           </p:txBody>
         </p:sp>
@@ -6424,7 +6425,7 @@
             <a:lstStyle/>
             <a:p>
               <a:pPr algn="ctr"/>
-              <a:endParaRPr lang="en-US"/>
+              <a:endParaRPr lang="en-US" sz="1799"/>
             </a:p>
           </p:txBody>
         </p:sp>
@@ -6473,7 +6474,7 @@
             <a:lstStyle/>
             <a:p>
               <a:pPr algn="ctr"/>
-              <a:endParaRPr lang="en-US"/>
+              <a:endParaRPr lang="en-US" sz="1799"/>
             </a:p>
           </p:txBody>
         </p:sp>
@@ -6522,7 +6523,7 @@
             <a:lstStyle/>
             <a:p>
               <a:pPr algn="ctr"/>
-              <a:endParaRPr lang="en-US"/>
+              <a:endParaRPr lang="en-US" sz="1799"/>
             </a:p>
           </p:txBody>
         </p:sp>
@@ -6569,7 +6570,7 @@
             <a:p>
               <a:pPr algn="ctr"/>
               <a:r>
-                <a:rPr lang="en-US" dirty="0"/>
+                <a:rPr lang="en-US" sz="1799" dirty="0"/>
                 <a:t>DAQ</a:t>
               </a:r>
             </a:p>
@@ -6673,8 +6674,8 @@
           </p:nvSpPr>
           <p:spPr>
             <a:xfrm>
-              <a:off x="3743325" y="3414325"/>
-              <a:ext cx="1100130" cy="276999"/>
+              <a:off x="3743325" y="3414326"/>
+              <a:ext cx="1100131" cy="276999"/>
             </a:xfrm>
             <a:prstGeom prst="rect">
               <a:avLst/>
@@ -6742,7 +6743,7 @@
             <a:lstStyle/>
             <a:p>
               <a:pPr algn="ctr"/>
-              <a:endParaRPr lang="en-US"/>
+              <a:endParaRPr lang="en-US" sz="1799"/>
             </a:p>
           </p:txBody>
         </p:sp>
@@ -6793,7 +6794,7 @@
             <a:lstStyle/>
             <a:p>
               <a:pPr algn="ctr"/>
-              <a:endParaRPr lang="en-US"/>
+              <a:endParaRPr lang="en-US" sz="1799"/>
             </a:p>
           </p:txBody>
         </p:sp>
@@ -6811,8 +6812,8 @@
           </p:nvSpPr>
           <p:spPr>
             <a:xfrm>
-              <a:off x="2588430" y="4095349"/>
-              <a:ext cx="1100130" cy="276999"/>
+              <a:off x="2588429" y="4095348"/>
+              <a:ext cx="1100131" cy="276999"/>
             </a:xfrm>
             <a:prstGeom prst="rect">
               <a:avLst/>
@@ -6884,7 +6885,7 @@
             <a:lstStyle/>
             <a:p>
               <a:pPr algn="ctr"/>
-              <a:endParaRPr lang="en-US"/>
+              <a:endParaRPr lang="en-US" sz="1799"/>
             </a:p>
           </p:txBody>
         </p:sp>
@@ -6939,7 +6940,7 @@
             <a:lstStyle/>
             <a:p>
               <a:pPr algn="ctr"/>
-              <a:endParaRPr lang="en-US"/>
+              <a:endParaRPr lang="en-US" sz="1799"/>
             </a:p>
           </p:txBody>
         </p:sp>
@@ -7041,8 +7042,8 @@
           </p:nvSpPr>
           <p:spPr>
             <a:xfrm>
-              <a:off x="4962504" y="4171950"/>
-              <a:ext cx="706271" cy="276999"/>
+              <a:off x="4962506" y="4171951"/>
+              <a:ext cx="706269" cy="276999"/>
             </a:xfrm>
             <a:prstGeom prst="rect">
               <a:avLst/>
@@ -7077,8 +7078,8 @@
           </p:nvSpPr>
           <p:spPr>
             <a:xfrm>
-              <a:off x="4465802" y="4443668"/>
-              <a:ext cx="706271" cy="276999"/>
+              <a:off x="4465802" y="4443667"/>
+              <a:ext cx="706269" cy="276999"/>
             </a:xfrm>
             <a:prstGeom prst="rect">
               <a:avLst/>
@@ -7156,7 +7157,7 @@
           <p:spPr>
             <a:xfrm>
               <a:off x="635838" y="3414324"/>
-              <a:ext cx="645309" cy="276999"/>
+              <a:ext cx="645310" cy="276999"/>
             </a:xfrm>
             <a:prstGeom prst="rect">
               <a:avLst/>
@@ -7191,8 +7192,8 @@
           </p:nvSpPr>
           <p:spPr>
             <a:xfrm>
-              <a:off x="2882506" y="2556402"/>
-              <a:ext cx="645309" cy="276999"/>
+              <a:off x="2882507" y="2556401"/>
+              <a:ext cx="645310" cy="276999"/>
             </a:xfrm>
             <a:prstGeom prst="rect">
               <a:avLst/>
@@ -7279,8 +7280,8 @@
           </p:nvPr>
         </p:nvGraphicFramePr>
         <p:xfrm>
-          <a:off x="5638078" y="1991500"/>
-          <a:ext cx="5596359" cy="1762122"/>
+          <a:off x="5638078" y="1991499"/>
+          <a:ext cx="5596360" cy="2079330"/>
         </p:xfrm>
         <a:graphic>
           <a:graphicData uri="http://schemas.openxmlformats.org/drawingml/2006/table">
@@ -7303,7 +7304,7 @@
                     </a:ext>
                   </a:extLst>
                 </a:gridCol>
-                <a:gridCol w="1372887">
+                <a:gridCol w="1372888">
                   <a:extLst>
                     <a:ext uri="{9D8B030D-6E8A-4147-A177-3AD203B41FA5}">
                       <a16:colId xmlns:a16="http://schemas.microsoft.com/office/drawing/2014/main" val="8266974"/>
@@ -7311,19 +7312,19 @@
                   </a:extLst>
                 </a:gridCol>
               </a:tblGrid>
-              <a:tr h="390522">
+              <a:tr h="390523">
                 <a:tc>
                   <a:txBody>
                     <a:bodyPr/>
                     <a:lstStyle/>
                     <a:p>
                       <a:r>
-                        <a:rPr lang="en-US" sz="1200" dirty="0"/>
+                        <a:rPr lang="en-US" sz="1300" dirty="0"/>
                         <a:t>Property:</a:t>
                       </a:r>
                     </a:p>
                   </a:txBody>
-                  <a:tcPr/>
+                  <a:tcPr marL="91439" marR="91439"/>
                 </a:tc>
                 <a:tc>
                   <a:txBody>
@@ -7331,12 +7332,12 @@
                     <a:lstStyle/>
                     <a:p>
                       <a:r>
-                        <a:rPr lang="en-US" sz="1200" dirty="0"/>
+                        <a:rPr lang="en-US" sz="1300" dirty="0"/>
                         <a:t>Value</a:t>
                       </a:r>
                     </a:p>
                   </a:txBody>
-                  <a:tcPr/>
+                  <a:tcPr marL="91439" marR="91439"/>
                 </a:tc>
                 <a:tc>
                   <a:txBody>
@@ -7344,12 +7345,12 @@
                     <a:lstStyle/>
                     <a:p>
                       <a:r>
-                        <a:rPr lang="en-US" sz="1200" dirty="0"/>
+                        <a:rPr lang="en-US" sz="1300" dirty="0"/>
                         <a:t>Units</a:t>
                       </a:r>
                     </a:p>
                   </a:txBody>
-                  <a:tcPr/>
+                  <a:tcPr marL="91439" marR="91439"/>
                 </a:tc>
                 <a:extLst>
                   <a:ext uri="{0D108BD9-81ED-4DB2-BD59-A6C34878D82A}">
@@ -7357,19 +7358,19 @@
                   </a:ext>
                 </a:extLst>
               </a:tr>
-              <a:tr h="182880">
+              <a:tr h="296708">
                 <a:tc>
                   <a:txBody>
                     <a:bodyPr/>
                     <a:lstStyle/>
                     <a:p>
                       <a:r>
-                        <a:rPr lang="en-US" sz="1200" dirty="0"/>
+                        <a:rPr lang="en-US" sz="1300" dirty="0"/>
                         <a:t>Flap mass</a:t>
                       </a:r>
                     </a:p>
                   </a:txBody>
-                  <a:tcPr/>
+                  <a:tcPr marL="91439" marR="91439"/>
                 </a:tc>
                 <a:tc>
                   <a:txBody>
@@ -7377,12 +7378,12 @@
                     <a:lstStyle/>
                     <a:p>
                       <a:r>
-                        <a:rPr lang="en-US" sz="1200" dirty="0"/>
+                        <a:rPr lang="en-US" sz="1300" dirty="0"/>
                         <a:t>23.1</a:t>
                       </a:r>
                     </a:p>
                   </a:txBody>
-                  <a:tcPr/>
+                  <a:tcPr marL="91439" marR="91439"/>
                 </a:tc>
                 <a:tc>
                   <a:txBody>
@@ -7390,12 +7391,12 @@
                     <a:lstStyle/>
                     <a:p>
                       <a:r>
-                        <a:rPr lang="en-US" sz="1200" dirty="0"/>
+                        <a:rPr lang="en-US" sz="1300" dirty="0"/>
                         <a:t>kg</a:t>
                       </a:r>
                     </a:p>
                   </a:txBody>
-                  <a:tcPr/>
+                  <a:tcPr marL="91439" marR="91439"/>
                 </a:tc>
                 <a:extLst>
                   <a:ext uri="{0D108BD9-81ED-4DB2-BD59-A6C34878D82A}">
@@ -7403,19 +7404,19 @@
                   </a:ext>
                 </a:extLst>
               </a:tr>
-              <a:tr h="182880">
+              <a:tr h="296708">
                 <a:tc>
                   <a:txBody>
                     <a:bodyPr/>
                     <a:lstStyle/>
                     <a:p>
                       <a:r>
-                        <a:rPr lang="en-US" sz="1200" dirty="0"/>
+                        <a:rPr lang="en-US" sz="1300" dirty="0"/>
                         <a:t>Platform mass</a:t>
                       </a:r>
                     </a:p>
                   </a:txBody>
-                  <a:tcPr/>
+                  <a:tcPr marL="91439" marR="91439"/>
                 </a:tc>
                 <a:tc>
                   <a:txBody>
@@ -7423,12 +7424,12 @@
                     <a:lstStyle/>
                     <a:p>
                       <a:r>
-                        <a:rPr lang="en-US" sz="1200" dirty="0"/>
+                        <a:rPr lang="en-US" sz="1300" dirty="0"/>
                         <a:t>189.8</a:t>
                       </a:r>
                     </a:p>
                   </a:txBody>
-                  <a:tcPr/>
+                  <a:tcPr marL="91439" marR="91439"/>
                 </a:tc>
                 <a:tc>
                   <a:txBody>
@@ -7436,12 +7437,12 @@
                     <a:lstStyle/>
                     <a:p>
                       <a:r>
-                        <a:rPr lang="en-US" sz="1200" dirty="0"/>
+                        <a:rPr lang="en-US" sz="1300" dirty="0"/>
                         <a:t>kg</a:t>
                       </a:r>
                     </a:p>
                   </a:txBody>
-                  <a:tcPr/>
+                  <a:tcPr marL="91439" marR="91439"/>
                 </a:tc>
                 <a:extLst>
                   <a:ext uri="{0D108BD9-81ED-4DB2-BD59-A6C34878D82A}">
@@ -7449,19 +7450,19 @@
                   </a:ext>
                 </a:extLst>
               </a:tr>
-              <a:tr h="182880">
+              <a:tr h="296708">
                 <a:tc>
                   <a:txBody>
                     <a:bodyPr/>
                     <a:lstStyle/>
                     <a:p>
                       <a:r>
-                        <a:rPr lang="en-US" sz="1200" dirty="0"/>
+                        <a:rPr lang="en-US" sz="1300" dirty="0"/>
                         <a:t>Mooring stiffness</a:t>
                       </a:r>
                     </a:p>
                   </a:txBody>
-                  <a:tcPr/>
+                  <a:tcPr marL="91439" marR="91439"/>
                 </a:tc>
                 <a:tc>
                   <a:txBody>
@@ -7469,12 +7470,12 @@
                     <a:lstStyle/>
                     <a:p>
                       <a:r>
-                        <a:rPr lang="en-US" sz="1200" dirty="0"/>
+                        <a:rPr lang="en-US" sz="1300" dirty="0"/>
                         <a:t>[1e5, 0, 1e5, 0, 1e5]</a:t>
                       </a:r>
                     </a:p>
                   </a:txBody>
-                  <a:tcPr/>
+                  <a:tcPr marL="91439" marR="91439"/>
                 </a:tc>
                 <a:tc>
                   <a:txBody>
@@ -7482,12 +7483,12 @@
                     <a:lstStyle/>
                     <a:p>
                       <a:r>
-                        <a:rPr lang="en-US" sz="1200" dirty="0"/>
+                        <a:rPr lang="en-US" sz="1300" dirty="0"/>
                         <a:t>N/m</a:t>
                       </a:r>
                     </a:p>
                   </a:txBody>
-                  <a:tcPr/>
+                  <a:tcPr marL="91439" marR="91439"/>
                 </a:tc>
                 <a:extLst>
                   <a:ext uri="{0D108BD9-81ED-4DB2-BD59-A6C34878D82A}">
@@ -7495,19 +7496,19 @@
                   </a:ext>
                 </a:extLst>
               </a:tr>
-              <a:tr h="182880">
+              <a:tr h="296708">
                 <a:tc>
                   <a:txBody>
                     <a:bodyPr/>
                     <a:lstStyle/>
                     <a:p>
                       <a:r>
-                        <a:rPr lang="en-US" sz="1200" dirty="0"/>
+                        <a:rPr lang="en-US" sz="1300" dirty="0"/>
                         <a:t>Mooring damping</a:t>
                       </a:r>
                     </a:p>
                   </a:txBody>
-                  <a:tcPr/>
+                  <a:tcPr marL="91439" marR="91439"/>
                 </a:tc>
                 <a:tc>
                   <a:txBody>
@@ -7515,12 +7516,12 @@
                     <a:lstStyle/>
                     <a:p>
                       <a:r>
-                        <a:rPr lang="en-US" sz="1200" dirty="0"/>
+                        <a:rPr lang="en-US" sz="1300" dirty="0"/>
                         <a:t>[1e4, 0, 1e4, 0, 1e4]</a:t>
                       </a:r>
                     </a:p>
                   </a:txBody>
-                  <a:tcPr/>
+                  <a:tcPr marL="91439" marR="91439"/>
                 </a:tc>
                 <a:tc>
                   <a:txBody>
@@ -7528,12 +7529,12 @@
                     <a:lstStyle/>
                     <a:p>
                       <a:r>
-                        <a:rPr lang="en-US" sz="1200" dirty="0"/>
+                        <a:rPr lang="en-US" sz="1300" dirty="0"/>
                         <a:t>Ns/m</a:t>
                       </a:r>
                     </a:p>
                   </a:txBody>
-                  <a:tcPr/>
+                  <a:tcPr marL="91439" marR="91439"/>
                 </a:tc>
                 <a:extLst>
                   <a:ext uri="{0D108BD9-81ED-4DB2-BD59-A6C34878D82A}">
@@ -7541,19 +7542,19 @@
                   </a:ext>
                 </a:extLst>
               </a:tr>
-              <a:tr h="182880">
+              <a:tr h="501975">
                 <a:tc>
                   <a:txBody>
                     <a:bodyPr/>
                     <a:lstStyle/>
                     <a:p>
                       <a:r>
-                        <a:rPr lang="en-US" sz="1200" dirty="0"/>
+                        <a:rPr lang="en-US" sz="1300" dirty="0"/>
                         <a:t>Mooring pretension (heave)</a:t>
                       </a:r>
                     </a:p>
                   </a:txBody>
-                  <a:tcPr/>
+                  <a:tcPr marL="91439" marR="91439"/>
                 </a:tc>
                 <a:tc>
                   <a:txBody>
@@ -7561,12 +7562,12 @@
                     <a:lstStyle/>
                     <a:p>
                       <a:r>
-                        <a:rPr lang="en-US" sz="1200" dirty="0"/>
+                        <a:rPr lang="en-US" sz="1300" dirty="0"/>
                         <a:t>-273.0614</a:t>
                       </a:r>
                     </a:p>
                   </a:txBody>
-                  <a:tcPr/>
+                  <a:tcPr marL="91439" marR="91439"/>
                 </a:tc>
                 <a:tc>
                   <a:txBody>
@@ -7574,12 +7575,12 @@
                     <a:lstStyle/>
                     <a:p>
                       <a:r>
-                        <a:rPr lang="en-US" sz="1200" dirty="0"/>
+                        <a:rPr lang="en-US" sz="1300" dirty="0"/>
                         <a:t>N</a:t>
                       </a:r>
                     </a:p>
                   </a:txBody>
-                  <a:tcPr/>
+                  <a:tcPr marL="91439" marR="91439"/>
                 </a:tc>
                 <a:extLst>
                   <a:ext uri="{0D108BD9-81ED-4DB2-BD59-A6C34878D82A}">
@@ -7635,8 +7636,8 @@
         </p:nvGrpSpPr>
         <p:grpSpPr>
           <a:xfrm>
-            <a:off x="406471" y="907427"/>
-            <a:ext cx="6862759" cy="4076057"/>
+            <a:off x="406474" y="907430"/>
+            <a:ext cx="6862760" cy="4076056"/>
             <a:chOff x="406471" y="907427"/>
             <a:chExt cx="6862759" cy="4076057"/>
           </a:xfrm>
@@ -7684,7 +7685,7 @@
             <a:p>
               <a:pPr algn="ctr"/>
               <a:r>
-                <a:rPr lang="en-US" dirty="0"/>
+                <a:rPr lang="en-US" sz="1799" dirty="0"/>
                 <a:t>DAQ</a:t>
               </a:r>
             </a:p>
@@ -7742,7 +7743,7 @@
             <a:lstStyle/>
             <a:p>
               <a:pPr algn="ctr"/>
-              <a:endParaRPr lang="en-US"/>
+              <a:endParaRPr lang="en-US" sz="1799"/>
             </a:p>
           </p:txBody>
         </p:sp>
@@ -7798,7 +7799,7 @@
             <a:lstStyle/>
             <a:p>
               <a:pPr algn="ctr"/>
-              <a:endParaRPr lang="en-US"/>
+              <a:endParaRPr lang="en-US" sz="1799"/>
             </a:p>
           </p:txBody>
         </p:sp>
@@ -7852,7 +7853,7 @@
             <a:lstStyle/>
             <a:p>
               <a:pPr algn="ctr"/>
-              <a:endParaRPr lang="en-US"/>
+              <a:endParaRPr lang="en-US" sz="1799"/>
             </a:p>
           </p:txBody>
         </p:sp>
@@ -7945,7 +7946,7 @@
             <a:lstStyle/>
             <a:p>
               <a:pPr algn="ctr"/>
-              <a:endParaRPr lang="en-US"/>
+              <a:endParaRPr lang="en-US" sz="1799"/>
             </a:p>
           </p:txBody>
         </p:sp>
@@ -7996,7 +7997,7 @@
             <a:lstStyle/>
             <a:p>
               <a:pPr algn="ctr"/>
-              <a:endParaRPr lang="en-US"/>
+              <a:endParaRPr lang="en-US" sz="1799"/>
             </a:p>
           </p:txBody>
         </p:sp>
@@ -8042,7 +8043,7 @@
             <a:lstStyle/>
             <a:p>
               <a:pPr algn="ctr"/>
-              <a:endParaRPr lang="en-US"/>
+              <a:endParaRPr lang="en-US" sz="1799"/>
             </a:p>
           </p:txBody>
         </p:sp>
@@ -8088,7 +8089,7 @@
             <a:lstStyle/>
             <a:p>
               <a:pPr algn="ctr"/>
-              <a:endParaRPr lang="en-US"/>
+              <a:endParaRPr lang="en-US" sz="1799"/>
             </a:p>
           </p:txBody>
         </p:sp>
@@ -8107,7 +8108,7 @@
           <p:spPr>
             <a:xfrm>
               <a:off x="2662908" y="4027993"/>
-              <a:ext cx="1921264" cy="369332"/>
+              <a:ext cx="1921264" cy="369204"/>
             </a:xfrm>
             <a:prstGeom prst="rect">
               <a:avLst/>
@@ -8122,7 +8123,7 @@
             <a:p>
               <a:pPr algn="ctr"/>
               <a:r>
-                <a:rPr lang="en-US" dirty="0"/>
+                <a:rPr lang="en-US" sz="1799" dirty="0"/>
                 <a:t>Platform</a:t>
               </a:r>
             </a:p>
@@ -8233,7 +8234,7 @@
           <p:spPr>
             <a:xfrm>
               <a:off x="1928151" y="2284874"/>
-              <a:ext cx="781045" cy="369332"/>
+              <a:ext cx="781045" cy="369204"/>
             </a:xfrm>
             <a:prstGeom prst="rect">
               <a:avLst/>
@@ -8247,14 +8248,14 @@
             <a:lstStyle/>
             <a:p>
               <a:r>
-                <a:rPr lang="en-US" dirty="0"/>
+                <a:rPr lang="en-US" sz="1799" dirty="0"/>
                 <a:t>6 </a:t>
               </a:r>
               <a:r>
-                <a:rPr lang="en-US" dirty="0" err="1"/>
+                <a:rPr lang="en-US" sz="1799" dirty="0" err="1"/>
                 <a:t>dof</a:t>
               </a:r>
-              <a:endParaRPr lang="en-US" dirty="0"/>
+              <a:endParaRPr lang="en-US" sz="1799" dirty="0"/>
             </a:p>
           </p:txBody>
         </p:sp>
@@ -8272,8 +8273,8 @@
           </p:nvSpPr>
           <p:spPr>
             <a:xfrm>
-              <a:off x="3839699" y="3605131"/>
-              <a:ext cx="781045" cy="369332"/>
+              <a:off x="3839700" y="3605132"/>
+              <a:ext cx="781045" cy="369204"/>
             </a:xfrm>
             <a:prstGeom prst="rect">
               <a:avLst/>
@@ -8287,14 +8288,14 @@
             <a:lstStyle/>
             <a:p>
               <a:r>
-                <a:rPr lang="en-US" dirty="0"/>
+                <a:rPr lang="en-US" sz="1799" dirty="0"/>
                 <a:t>6 </a:t>
               </a:r>
               <a:r>
-                <a:rPr lang="en-US" dirty="0" err="1"/>
+                <a:rPr lang="en-US" sz="1799" dirty="0" err="1"/>
                 <a:t>dof</a:t>
               </a:r>
-              <a:endParaRPr lang="en-US" dirty="0"/>
+              <a:endParaRPr lang="en-US" sz="1799" dirty="0"/>
             </a:p>
           </p:txBody>
         </p:sp>
@@ -8312,8 +8313,8 @@
           </p:nvSpPr>
           <p:spPr>
             <a:xfrm>
-              <a:off x="6488185" y="2184666"/>
-              <a:ext cx="781045" cy="369332"/>
+              <a:off x="6488185" y="2184665"/>
+              <a:ext cx="781045" cy="369204"/>
             </a:xfrm>
             <a:prstGeom prst="rect">
               <a:avLst/>
@@ -8327,14 +8328,14 @@
             <a:lstStyle/>
             <a:p>
               <a:r>
-                <a:rPr lang="en-US" dirty="0"/>
+                <a:rPr lang="en-US" sz="1799" dirty="0"/>
                 <a:t>6 </a:t>
               </a:r>
               <a:r>
-                <a:rPr lang="en-US" dirty="0" err="1"/>
+                <a:rPr lang="en-US" sz="1799" dirty="0" err="1"/>
                 <a:t>dof</a:t>
               </a:r>
-              <a:endParaRPr lang="en-US" dirty="0"/>
+              <a:endParaRPr lang="en-US" sz="1799" dirty="0"/>
             </a:p>
           </p:txBody>
         </p:sp>
@@ -8377,10 +8378,10 @@
       </p:grpSpPr>
       <p:grpSp>
         <p:nvGrpSpPr>
-          <p:cNvPr id="19" name="Group 18">
+          <p:cNvPr id="5" name="Group 4">
             <a:extLst>
               <a:ext uri="{FF2B5EF4-FFF2-40B4-BE49-F238E27FC236}">
-                <a16:creationId xmlns:a16="http://schemas.microsoft.com/office/drawing/2014/main" id="{D499368E-3F94-378C-17DB-3EF56DBFAB95}"/>
+                <a16:creationId xmlns:a16="http://schemas.microsoft.com/office/drawing/2014/main" id="{2C3F18C4-C3D7-1C09-9CEB-1F138C6FF28B}"/>
               </a:ext>
             </a:extLst>
           </p:cNvPr>
@@ -8389,18 +8390,18 @@
         </p:nvGrpSpPr>
         <p:grpSpPr>
           <a:xfrm>
-            <a:off x="406471" y="907427"/>
-            <a:ext cx="6862759" cy="4175809"/>
+            <a:off x="406472" y="907426"/>
+            <a:ext cx="6572251" cy="4175811"/>
             <a:chOff x="406471" y="907427"/>
-            <a:chExt cx="6862759" cy="4175809"/>
+            <a:chExt cx="6572250" cy="4175809"/>
           </a:xfrm>
         </p:grpSpPr>
         <p:grpSp>
           <p:nvGrpSpPr>
-            <p:cNvPr id="65" name="Group 64">
-              <a:extLst>
-                <a:ext uri="{FF2B5EF4-FFF2-40B4-BE49-F238E27FC236}">
-                  <a16:creationId xmlns:a16="http://schemas.microsoft.com/office/drawing/2014/main" id="{D1C7D085-8EFF-A419-A1E9-E856892310B0}"/>
+            <p:cNvPr id="19" name="Group 18">
+              <a:extLst>
+                <a:ext uri="{FF2B5EF4-FFF2-40B4-BE49-F238E27FC236}">
+                  <a16:creationId xmlns:a16="http://schemas.microsoft.com/office/drawing/2014/main" id="{D499368E-3F94-378C-17DB-3EF56DBFAB95}"/>
                 </a:ext>
               </a:extLst>
             </p:cNvPr>
@@ -8410,17 +8411,722 @@
           <p:grpSpPr>
             <a:xfrm>
               <a:off x="406471" y="907427"/>
-              <a:ext cx="6862759" cy="3908417"/>
+              <a:ext cx="6572250" cy="4175809"/>
               <a:chOff x="406471" y="907427"/>
-              <a:chExt cx="6862759" cy="3908417"/>
+              <a:chExt cx="6572250" cy="4175809"/>
             </a:xfrm>
           </p:grpSpPr>
+          <p:grpSp>
+            <p:nvGrpSpPr>
+              <p:cNvPr id="65" name="Group 64">
+                <a:extLst>
+                  <a:ext uri="{FF2B5EF4-FFF2-40B4-BE49-F238E27FC236}">
+                    <a16:creationId xmlns:a16="http://schemas.microsoft.com/office/drawing/2014/main" id="{D1C7D085-8EFF-A419-A1E9-E856892310B0}"/>
+                  </a:ext>
+                </a:extLst>
+              </p:cNvPr>
+              <p:cNvGrpSpPr/>
+              <p:nvPr/>
+            </p:nvGrpSpPr>
+            <p:grpSpPr>
+              <a:xfrm>
+                <a:off x="406471" y="907427"/>
+                <a:ext cx="6572250" cy="3908417"/>
+                <a:chOff x="406471" y="907427"/>
+                <a:chExt cx="6572250" cy="3908417"/>
+              </a:xfrm>
+            </p:grpSpPr>
+            <p:sp>
+              <p:nvSpPr>
+                <p:cNvPr id="6" name="Rectangle 5">
+                  <a:extLst>
+                    <a:ext uri="{FF2B5EF4-FFF2-40B4-BE49-F238E27FC236}">
+                      <a16:creationId xmlns:a16="http://schemas.microsoft.com/office/drawing/2014/main" id="{6240C082-5286-F6D8-2749-57351556C480}"/>
+                    </a:ext>
+                  </a:extLst>
+                </p:cNvPr>
+                <p:cNvSpPr/>
+                <p:nvPr/>
+              </p:nvSpPr>
+              <p:spPr>
+                <a:xfrm>
+                  <a:off x="2616271" y="4291762"/>
+                  <a:ext cx="2014538" cy="401056"/>
+                </a:xfrm>
+                <a:prstGeom prst="rect">
+                  <a:avLst/>
+                </a:prstGeom>
+              </p:spPr>
+              <p:style>
+                <a:lnRef idx="2">
+                  <a:schemeClr val="accent1">
+                    <a:shade val="15000"/>
+                  </a:schemeClr>
+                </a:lnRef>
+                <a:fillRef idx="1">
+                  <a:schemeClr val="accent1"/>
+                </a:fillRef>
+                <a:effectRef idx="0">
+                  <a:schemeClr val="accent1"/>
+                </a:effectRef>
+                <a:fontRef idx="minor">
+                  <a:schemeClr val="lt1"/>
+                </a:fontRef>
+              </p:style>
+              <p:txBody>
+                <a:bodyPr rtlCol="0" anchor="ctr"/>
+                <a:lstStyle/>
+                <a:p>
+                  <a:pPr algn="ctr"/>
+                  <a:r>
+                    <a:rPr lang="en-US" sz="1799" dirty="0"/>
+                    <a:t>DAQ</a:t>
+                  </a:r>
+                </a:p>
+              </p:txBody>
+            </p:sp>
+            <p:sp>
+              <p:nvSpPr>
+                <p:cNvPr id="7" name="Rectangle 6">
+                  <a:extLst>
+                    <a:ext uri="{FF2B5EF4-FFF2-40B4-BE49-F238E27FC236}">
+                      <a16:creationId xmlns:a16="http://schemas.microsoft.com/office/drawing/2014/main" id="{FD4DC6E5-085E-29CE-AE3E-00A3DA69310A}"/>
+                    </a:ext>
+                  </a:extLst>
+                </p:cNvPr>
+                <p:cNvSpPr/>
+                <p:nvPr/>
+              </p:nvSpPr>
+              <p:spPr>
+                <a:xfrm>
+                  <a:off x="1020836" y="907427"/>
+                  <a:ext cx="781045" cy="3908417"/>
+                </a:xfrm>
+                <a:prstGeom prst="rect">
+                  <a:avLst/>
+                </a:prstGeom>
+                <a:solidFill>
+                  <a:schemeClr val="bg1"/>
+                </a:solidFill>
+                <a:ln w="28575">
+                  <a:solidFill>
+                    <a:schemeClr val="bg1">
+                      <a:lumMod val="50000"/>
+                    </a:schemeClr>
+                  </a:solidFill>
+                </a:ln>
+              </p:spPr>
+              <p:style>
+                <a:lnRef idx="2">
+                  <a:schemeClr val="accent1">
+                    <a:shade val="15000"/>
+                  </a:schemeClr>
+                </a:lnRef>
+                <a:fillRef idx="1">
+                  <a:schemeClr val="accent1"/>
+                </a:fillRef>
+                <a:effectRef idx="0">
+                  <a:schemeClr val="accent1"/>
+                </a:effectRef>
+                <a:fontRef idx="minor">
+                  <a:schemeClr val="lt1"/>
+                </a:fontRef>
+              </p:style>
+              <p:txBody>
+                <a:bodyPr rtlCol="0" anchor="ctr"/>
+                <a:lstStyle/>
+                <a:p>
+                  <a:pPr algn="ctr"/>
+                  <a:endParaRPr lang="en-US" sz="1799"/>
+                </a:p>
+              </p:txBody>
+            </p:sp>
+            <p:sp>
+              <p:nvSpPr>
+                <p:cNvPr id="8" name="Rectangle 7">
+                  <a:extLst>
+                    <a:ext uri="{FF2B5EF4-FFF2-40B4-BE49-F238E27FC236}">
+                      <a16:creationId xmlns:a16="http://schemas.microsoft.com/office/drawing/2014/main" id="{E5C75B8F-0D1B-D99E-328B-710285BFB2B9}"/>
+                    </a:ext>
+                  </a:extLst>
+                </p:cNvPr>
+                <p:cNvSpPr/>
+                <p:nvPr/>
+              </p:nvSpPr>
+              <p:spPr>
+                <a:xfrm>
+                  <a:off x="5559497" y="969782"/>
+                  <a:ext cx="781045" cy="3846060"/>
+                </a:xfrm>
+                <a:prstGeom prst="rect">
+                  <a:avLst/>
+                </a:prstGeom>
+                <a:solidFill>
+                  <a:schemeClr val="bg1"/>
+                </a:solidFill>
+                <a:ln w="28575">
+                  <a:solidFill>
+                    <a:schemeClr val="bg1">
+                      <a:lumMod val="50000"/>
+                    </a:schemeClr>
+                  </a:solidFill>
+                </a:ln>
+              </p:spPr>
+              <p:style>
+                <a:lnRef idx="2">
+                  <a:schemeClr val="accent1">
+                    <a:shade val="15000"/>
+                  </a:schemeClr>
+                </a:lnRef>
+                <a:fillRef idx="1">
+                  <a:schemeClr val="accent1"/>
+                </a:fillRef>
+                <a:effectRef idx="0">
+                  <a:schemeClr val="accent1"/>
+                </a:effectRef>
+                <a:fontRef idx="minor">
+                  <a:schemeClr val="lt1"/>
+                </a:fontRef>
+              </p:style>
+              <p:txBody>
+                <a:bodyPr rtlCol="0" anchor="ctr"/>
+                <a:lstStyle/>
+                <a:p>
+                  <a:pPr algn="ctr"/>
+                  <a:endParaRPr lang="en-US" sz="1799"/>
+                </a:p>
+              </p:txBody>
+            </p:sp>
+            <p:sp>
+              <p:nvSpPr>
+                <p:cNvPr id="9" name="Trapezoid 8">
+                  <a:extLst>
+                    <a:ext uri="{FF2B5EF4-FFF2-40B4-BE49-F238E27FC236}">
+                      <a16:creationId xmlns:a16="http://schemas.microsoft.com/office/drawing/2014/main" id="{5209F7CC-7B6D-B6A2-5705-4ECC1CE773EB}"/>
+                    </a:ext>
+                  </a:extLst>
+                </p:cNvPr>
+                <p:cNvSpPr/>
+                <p:nvPr/>
+              </p:nvSpPr>
+              <p:spPr>
+                <a:xfrm flipH="1" flipV="1">
+                  <a:off x="1225618" y="1591374"/>
+                  <a:ext cx="409575" cy="2333622"/>
+                </a:xfrm>
+                <a:prstGeom prst="trapezoid">
+                  <a:avLst/>
+                </a:prstGeom>
+                <a:solidFill>
+                  <a:srgbClr val="C00000">
+                    <a:alpha val="50000"/>
+                  </a:srgbClr>
+                </a:solidFill>
+                <a:ln>
+                  <a:prstDash val="dash"/>
+                </a:ln>
+              </p:spPr>
+              <p:style>
+                <a:lnRef idx="2">
+                  <a:schemeClr val="accent1">
+                    <a:shade val="15000"/>
+                  </a:schemeClr>
+                </a:lnRef>
+                <a:fillRef idx="1">
+                  <a:schemeClr val="accent1"/>
+                </a:fillRef>
+                <a:effectRef idx="0">
+                  <a:schemeClr val="accent1"/>
+                </a:effectRef>
+                <a:fontRef idx="minor">
+                  <a:schemeClr val="lt1"/>
+                </a:fontRef>
+              </p:style>
+              <p:txBody>
+                <a:bodyPr rtlCol="0" anchor="ctr"/>
+                <a:lstStyle/>
+                <a:p>
+                  <a:pPr algn="ctr"/>
+                  <a:endParaRPr lang="en-US" sz="1799"/>
+                </a:p>
+              </p:txBody>
+            </p:sp>
+            <p:cxnSp>
+              <p:nvCxnSpPr>
+                <p:cNvPr id="10" name="Straight Connector 9">
+                  <a:extLst>
+                    <a:ext uri="{FF2B5EF4-FFF2-40B4-BE49-F238E27FC236}">
+                      <a16:creationId xmlns:a16="http://schemas.microsoft.com/office/drawing/2014/main" id="{2573B160-1E6A-F63D-5787-60E43AF7ECA8}"/>
+                    </a:ext>
+                  </a:extLst>
+                </p:cNvPr>
+                <p:cNvCxnSpPr>
+                  <a:cxnSpLocks/>
+                </p:cNvCxnSpPr>
+                <p:nvPr/>
+              </p:nvCxnSpPr>
+              <p:spPr>
+                <a:xfrm>
+                  <a:off x="406471" y="1546046"/>
+                  <a:ext cx="6572250" cy="0"/>
+                </a:xfrm>
+                <a:prstGeom prst="line">
+                  <a:avLst/>
+                </a:prstGeom>
+                <a:ln w="38100"/>
+              </p:spPr>
+              <p:style>
+                <a:lnRef idx="2">
+                  <a:schemeClr val="accent1"/>
+                </a:lnRef>
+                <a:fillRef idx="0">
+                  <a:schemeClr val="accent1"/>
+                </a:fillRef>
+                <a:effectRef idx="1">
+                  <a:schemeClr val="accent1"/>
+                </a:effectRef>
+                <a:fontRef idx="minor">
+                  <a:schemeClr val="tx1"/>
+                </a:fontRef>
+              </p:style>
+            </p:cxnSp>
+            <p:sp>
+              <p:nvSpPr>
+                <p:cNvPr id="11" name="Trapezoid 10">
+                  <a:extLst>
+                    <a:ext uri="{FF2B5EF4-FFF2-40B4-BE49-F238E27FC236}">
+                      <a16:creationId xmlns:a16="http://schemas.microsoft.com/office/drawing/2014/main" id="{C7E8DB78-4CB3-0532-2E8F-50BB26AFBE32}"/>
+                    </a:ext>
+                  </a:extLst>
+                </p:cNvPr>
+                <p:cNvSpPr/>
+                <p:nvPr/>
+              </p:nvSpPr>
+              <p:spPr>
+                <a:xfrm flipH="1" flipV="1">
+                  <a:off x="5764280" y="1591374"/>
+                  <a:ext cx="409575" cy="2333622"/>
+                </a:xfrm>
+                <a:prstGeom prst="trapezoid">
+                  <a:avLst/>
+                </a:prstGeom>
+                <a:solidFill>
+                  <a:srgbClr val="C00000">
+                    <a:alpha val="50000"/>
+                  </a:srgbClr>
+                </a:solidFill>
+                <a:ln>
+                  <a:prstDash val="dash"/>
+                </a:ln>
+              </p:spPr>
+              <p:style>
+                <a:lnRef idx="2">
+                  <a:schemeClr val="accent1">
+                    <a:shade val="15000"/>
+                  </a:schemeClr>
+                </a:lnRef>
+                <a:fillRef idx="1">
+                  <a:schemeClr val="accent1"/>
+                </a:fillRef>
+                <a:effectRef idx="0">
+                  <a:schemeClr val="accent1"/>
+                </a:effectRef>
+                <a:fontRef idx="minor">
+                  <a:schemeClr val="lt1"/>
+                </a:fontRef>
+              </p:style>
+              <p:txBody>
+                <a:bodyPr rtlCol="0" anchor="ctr"/>
+                <a:lstStyle/>
+                <a:p>
+                  <a:pPr algn="ctr"/>
+                  <a:endParaRPr lang="en-US" sz="1799"/>
+                </a:p>
+              </p:txBody>
+            </p:sp>
+            <p:sp>
+              <p:nvSpPr>
+                <p:cNvPr id="14" name="Rectangle 13">
+                  <a:extLst>
+                    <a:ext uri="{FF2B5EF4-FFF2-40B4-BE49-F238E27FC236}">
+                      <a16:creationId xmlns:a16="http://schemas.microsoft.com/office/drawing/2014/main" id="{219292C3-AA67-23A6-9D74-BA36E788B344}"/>
+                    </a:ext>
+                  </a:extLst>
+                </p:cNvPr>
+                <p:cNvSpPr/>
+                <p:nvPr/>
+              </p:nvSpPr>
+              <p:spPr>
+                <a:xfrm>
+                  <a:off x="1439928" y="4131697"/>
+                  <a:ext cx="4519615" cy="161924"/>
+                </a:xfrm>
+                <a:prstGeom prst="rect">
+                  <a:avLst/>
+                </a:prstGeom>
+                <a:solidFill>
+                  <a:schemeClr val="bg2">
+                    <a:lumMod val="75000"/>
+                  </a:schemeClr>
+                </a:solidFill>
+              </p:spPr>
+              <p:style>
+                <a:lnRef idx="2">
+                  <a:schemeClr val="accent1">
+                    <a:shade val="15000"/>
+                  </a:schemeClr>
+                </a:lnRef>
+                <a:fillRef idx="1">
+                  <a:schemeClr val="accent1"/>
+                </a:fillRef>
+                <a:effectRef idx="0">
+                  <a:schemeClr val="accent1"/>
+                </a:effectRef>
+                <a:fontRef idx="minor">
+                  <a:schemeClr val="lt1"/>
+                </a:fontRef>
+              </p:style>
+              <p:txBody>
+                <a:bodyPr rtlCol="0" anchor="ctr"/>
+                <a:lstStyle/>
+                <a:p>
+                  <a:pPr algn="ctr"/>
+                  <a:endParaRPr lang="en-US" sz="1799"/>
+                </a:p>
+              </p:txBody>
+            </p:sp>
+            <p:sp>
+              <p:nvSpPr>
+                <p:cNvPr id="38" name="Oval 37">
+                  <a:extLst>
+                    <a:ext uri="{FF2B5EF4-FFF2-40B4-BE49-F238E27FC236}">
+                      <a16:creationId xmlns:a16="http://schemas.microsoft.com/office/drawing/2014/main" id="{0E438C7E-CB09-C37A-5C68-CAC643B84434}"/>
+                    </a:ext>
+                  </a:extLst>
+                </p:cNvPr>
+                <p:cNvSpPr/>
+                <p:nvPr/>
+              </p:nvSpPr>
+              <p:spPr>
+                <a:xfrm>
+                  <a:off x="1358967" y="2698265"/>
+                  <a:ext cx="142875" cy="204788"/>
+                </a:xfrm>
+                <a:prstGeom prst="ellipse">
+                  <a:avLst/>
+                </a:prstGeom>
+              </p:spPr>
+              <p:style>
+                <a:lnRef idx="2">
+                  <a:schemeClr val="accent2">
+                    <a:shade val="15000"/>
+                  </a:schemeClr>
+                </a:lnRef>
+                <a:fillRef idx="1">
+                  <a:schemeClr val="accent2"/>
+                </a:fillRef>
+                <a:effectRef idx="0">
+                  <a:schemeClr val="accent2"/>
+                </a:effectRef>
+                <a:fontRef idx="minor">
+                  <a:schemeClr val="lt1"/>
+                </a:fontRef>
+              </p:style>
+              <p:txBody>
+                <a:bodyPr rtlCol="0" anchor="ctr"/>
+                <a:lstStyle/>
+                <a:p>
+                  <a:pPr algn="ctr"/>
+                  <a:endParaRPr lang="en-US" sz="1799"/>
+                </a:p>
+              </p:txBody>
+            </p:sp>
+            <p:sp>
+              <p:nvSpPr>
+                <p:cNvPr id="39" name="Oval 38">
+                  <a:extLst>
+                    <a:ext uri="{FF2B5EF4-FFF2-40B4-BE49-F238E27FC236}">
+                      <a16:creationId xmlns:a16="http://schemas.microsoft.com/office/drawing/2014/main" id="{9A7AD91F-B085-5939-BC7E-0F12239F186C}"/>
+                    </a:ext>
+                  </a:extLst>
+                </p:cNvPr>
+                <p:cNvSpPr/>
+                <p:nvPr/>
+              </p:nvSpPr>
+              <p:spPr>
+                <a:xfrm>
+                  <a:off x="5897628" y="2702641"/>
+                  <a:ext cx="142875" cy="204788"/>
+                </a:xfrm>
+                <a:prstGeom prst="ellipse">
+                  <a:avLst/>
+                </a:prstGeom>
+              </p:spPr>
+              <p:style>
+                <a:lnRef idx="2">
+                  <a:schemeClr val="accent2">
+                    <a:shade val="15000"/>
+                  </a:schemeClr>
+                </a:lnRef>
+                <a:fillRef idx="1">
+                  <a:schemeClr val="accent2"/>
+                </a:fillRef>
+                <a:effectRef idx="0">
+                  <a:schemeClr val="accent2"/>
+                </a:effectRef>
+                <a:fontRef idx="minor">
+                  <a:schemeClr val="lt1"/>
+                </a:fontRef>
+              </p:style>
+              <p:txBody>
+                <a:bodyPr rtlCol="0" anchor="ctr"/>
+                <a:lstStyle/>
+                <a:p>
+                  <a:pPr algn="ctr"/>
+                  <a:endParaRPr lang="en-US" sz="1799"/>
+                </a:p>
+              </p:txBody>
+            </p:sp>
+            <p:sp>
+              <p:nvSpPr>
+                <p:cNvPr id="54" name="TextBox 53">
+                  <a:extLst>
+                    <a:ext uri="{FF2B5EF4-FFF2-40B4-BE49-F238E27FC236}">
+                      <a16:creationId xmlns:a16="http://schemas.microsoft.com/office/drawing/2014/main" id="{1E04B801-D17B-DEFC-0687-7CBD3A848CCB}"/>
+                    </a:ext>
+                  </a:extLst>
+                </p:cNvPr>
+                <p:cNvSpPr txBox="1"/>
+                <p:nvPr/>
+              </p:nvSpPr>
+              <p:spPr>
+                <a:xfrm>
+                  <a:off x="2662908" y="4027995"/>
+                  <a:ext cx="1921264" cy="369204"/>
+                </a:xfrm>
+                <a:prstGeom prst="rect">
+                  <a:avLst/>
+                </a:prstGeom>
+                <a:noFill/>
+              </p:spPr>
+              <p:txBody>
+                <a:bodyPr wrap="square" rtlCol="0">
+                  <a:spAutoFit/>
+                </a:bodyPr>
+                <a:lstStyle/>
+                <a:p>
+                  <a:pPr algn="ctr"/>
+                  <a:r>
+                    <a:rPr lang="en-US" sz="1799" dirty="0"/>
+                    <a:t>Platform</a:t>
+                  </a:r>
+                </a:p>
+              </p:txBody>
+            </p:sp>
+            <p:sp>
+              <p:nvSpPr>
+                <p:cNvPr id="62" name="TextBox 61">
+                  <a:extLst>
+                    <a:ext uri="{FF2B5EF4-FFF2-40B4-BE49-F238E27FC236}">
+                      <a16:creationId xmlns:a16="http://schemas.microsoft.com/office/drawing/2014/main" id="{C06D07EC-6425-2466-9E94-B68138DBAE7D}"/>
+                    </a:ext>
+                  </a:extLst>
+                </p:cNvPr>
+                <p:cNvSpPr txBox="1"/>
+                <p:nvPr/>
+              </p:nvSpPr>
+              <p:spPr>
+                <a:xfrm>
+                  <a:off x="1791565" y="2275792"/>
+                  <a:ext cx="1831976" cy="646074"/>
+                </a:xfrm>
+                <a:prstGeom prst="rect">
+                  <a:avLst/>
+                </a:prstGeom>
+                <a:noFill/>
+              </p:spPr>
+              <p:txBody>
+                <a:bodyPr wrap="square" rtlCol="0">
+                  <a:spAutoFit/>
+                </a:bodyPr>
+                <a:lstStyle/>
+                <a:p>
+                  <a:r>
+                    <a:rPr lang="en-US" sz="1799" dirty="0"/>
+                    <a:t>1 degree of freedom</a:t>
+                  </a:r>
+                </a:p>
+              </p:txBody>
+            </p:sp>
+            <p:sp>
+              <p:nvSpPr>
+                <p:cNvPr id="63" name="TextBox 62">
+                  <a:extLst>
+                    <a:ext uri="{FF2B5EF4-FFF2-40B4-BE49-F238E27FC236}">
+                      <a16:creationId xmlns:a16="http://schemas.microsoft.com/office/drawing/2014/main" id="{E0F00F77-2C38-E382-E64B-EFD30C890F64}"/>
+                    </a:ext>
+                  </a:extLst>
+                </p:cNvPr>
+                <p:cNvSpPr txBox="1"/>
+                <p:nvPr/>
+              </p:nvSpPr>
+              <p:spPr>
+                <a:xfrm>
+                  <a:off x="3788996" y="3295724"/>
+                  <a:ext cx="1900239" cy="646074"/>
+                </a:xfrm>
+                <a:prstGeom prst="rect">
+                  <a:avLst/>
+                </a:prstGeom>
+                <a:noFill/>
+              </p:spPr>
+              <p:txBody>
+                <a:bodyPr wrap="square" rtlCol="0">
+                  <a:spAutoFit/>
+                </a:bodyPr>
+                <a:lstStyle/>
+                <a:p>
+                  <a:r>
+                    <a:rPr lang="en-US" sz="1799" dirty="0"/>
+                    <a:t>3 degrees of freedom</a:t>
+                  </a:r>
+                </a:p>
+              </p:txBody>
+            </p:sp>
+            <p:sp>
+              <p:nvSpPr>
+                <p:cNvPr id="64" name="TextBox 63">
+                  <a:extLst>
+                    <a:ext uri="{FF2B5EF4-FFF2-40B4-BE49-F238E27FC236}">
+                      <a16:creationId xmlns:a16="http://schemas.microsoft.com/office/drawing/2014/main" id="{0FD595FC-2231-FEC6-A71B-AA289363B104}"/>
+                    </a:ext>
+                  </a:extLst>
+                </p:cNvPr>
+                <p:cNvSpPr txBox="1"/>
+                <p:nvPr/>
+              </p:nvSpPr>
+              <p:spPr>
+                <a:xfrm>
+                  <a:off x="4321028" y="2341232"/>
+                  <a:ext cx="1309899" cy="646074"/>
+                </a:xfrm>
+                <a:prstGeom prst="rect">
+                  <a:avLst/>
+                </a:prstGeom>
+                <a:noFill/>
+              </p:spPr>
+              <p:txBody>
+                <a:bodyPr wrap="square" rtlCol="0">
+                  <a:spAutoFit/>
+                </a:bodyPr>
+                <a:lstStyle/>
+                <a:p>
+                  <a:r>
+                    <a:rPr lang="en-US" sz="1799" dirty="0"/>
+                    <a:t>1 degree of freedom</a:t>
+                  </a:r>
+                </a:p>
+              </p:txBody>
+            </p:sp>
+          </p:grpSp>
+          <p:cxnSp>
+            <p:nvCxnSpPr>
+              <p:cNvPr id="12" name="Straight Arrow Connector 11">
+                <a:extLst>
+                  <a:ext uri="{FF2B5EF4-FFF2-40B4-BE49-F238E27FC236}">
+                    <a16:creationId xmlns:a16="http://schemas.microsoft.com/office/drawing/2014/main" id="{FBD39DDA-34EC-AFAA-5CE8-C5F3F2614B26}"/>
+                  </a:ext>
+                </a:extLst>
+              </p:cNvPr>
+              <p:cNvCxnSpPr/>
+              <p:nvPr/>
+            </p:nvCxnSpPr>
+            <p:spPr>
+              <a:xfrm>
+                <a:off x="3626777" y="3603757"/>
+                <a:ext cx="0" cy="1479479"/>
+              </a:xfrm>
+              <a:prstGeom prst="straightConnector1">
+                <a:avLst/>
+              </a:prstGeom>
+              <a:ln w="38100">
+                <a:solidFill>
+                  <a:schemeClr val="accent6">
+                    <a:lumMod val="75000"/>
+                  </a:schemeClr>
+                </a:solidFill>
+                <a:headEnd type="triangle"/>
+                <a:tailEnd type="triangle"/>
+              </a:ln>
+            </p:spPr>
+            <p:style>
+              <a:lnRef idx="2">
+                <a:schemeClr val="dk1"/>
+              </a:lnRef>
+              <a:fillRef idx="0">
+                <a:schemeClr val="dk1"/>
+              </a:fillRef>
+              <a:effectRef idx="1">
+                <a:schemeClr val="dk1"/>
+              </a:effectRef>
+              <a:fontRef idx="minor">
+                <a:schemeClr val="tx1"/>
+              </a:fontRef>
+            </p:style>
+          </p:cxnSp>
+          <p:cxnSp>
+            <p:nvCxnSpPr>
+              <p:cNvPr id="13" name="Straight Arrow Connector 12">
+                <a:extLst>
+                  <a:ext uri="{FF2B5EF4-FFF2-40B4-BE49-F238E27FC236}">
+                    <a16:creationId xmlns:a16="http://schemas.microsoft.com/office/drawing/2014/main" id="{85DEEC32-100E-F1FC-19C0-CEDDEEE3184D}"/>
+                  </a:ext>
+                </a:extLst>
+              </p:cNvPr>
+              <p:cNvCxnSpPr>
+                <a:cxnSpLocks/>
+              </p:cNvCxnSpPr>
+              <p:nvPr/>
+            </p:nvCxnSpPr>
+            <p:spPr>
+              <a:xfrm>
+                <a:off x="2707552" y="4027993"/>
+                <a:ext cx="1724346" cy="0"/>
+              </a:xfrm>
+              <a:prstGeom prst="straightConnector1">
+                <a:avLst/>
+              </a:prstGeom>
+              <a:ln w="38100">
+                <a:solidFill>
+                  <a:schemeClr val="accent6">
+                    <a:lumMod val="75000"/>
+                  </a:schemeClr>
+                </a:solidFill>
+                <a:headEnd type="triangle"/>
+                <a:tailEnd type="triangle"/>
+              </a:ln>
+            </p:spPr>
+            <p:style>
+              <a:lnRef idx="2">
+                <a:schemeClr val="dk1"/>
+              </a:lnRef>
+              <a:fillRef idx="0">
+                <a:schemeClr val="dk1"/>
+              </a:fillRef>
+              <a:effectRef idx="1">
+                <a:schemeClr val="dk1"/>
+              </a:effectRef>
+              <a:fontRef idx="minor">
+                <a:schemeClr val="tx1"/>
+              </a:fontRef>
+            </p:style>
+          </p:cxnSp>
           <p:sp>
             <p:nvSpPr>
-              <p:cNvPr id="6" name="Rectangle 5">
+              <p:cNvPr id="16" name="Arrow: Curved Down 15">
                 <a:extLst>
                   <a:ext uri="{FF2B5EF4-FFF2-40B4-BE49-F238E27FC236}">
-                    <a16:creationId xmlns:a16="http://schemas.microsoft.com/office/drawing/2014/main" id="{6240C082-5286-F6D8-2749-57351556C480}"/>
+                    <a16:creationId xmlns:a16="http://schemas.microsoft.com/office/drawing/2014/main" id="{A9B4A184-71D4-CCBD-5018-EE022E130B22}"/>
                   </a:ext>
                 </a:extLst>
               </p:cNvPr>
@@ -8429,24 +9135,24 @@
             </p:nvSpPr>
             <p:spPr>
               <a:xfrm>
-                <a:off x="2616271" y="4291762"/>
-                <a:ext cx="2014538" cy="401056"/>
+                <a:off x="682695" y="1929428"/>
+                <a:ext cx="1457325" cy="385765"/>
               </a:xfrm>
-              <a:prstGeom prst="rect">
+              <a:prstGeom prst="curvedDownArrow">
                 <a:avLst/>
               </a:prstGeom>
             </p:spPr>
             <p:style>
               <a:lnRef idx="2">
-                <a:schemeClr val="accent1">
+                <a:schemeClr val="accent6">
                   <a:shade val="15000"/>
                 </a:schemeClr>
               </a:lnRef>
               <a:fillRef idx="1">
-                <a:schemeClr val="accent1"/>
+                <a:schemeClr val="accent6"/>
               </a:fillRef>
               <a:effectRef idx="0">
-                <a:schemeClr val="accent1"/>
+                <a:schemeClr val="accent6"/>
               </a:effectRef>
               <a:fontRef idx="minor">
                 <a:schemeClr val="lt1"/>
@@ -8457,19 +9163,20 @@
               <a:lstStyle/>
               <a:p>
                 <a:pPr algn="ctr"/>
-                <a:r>
-                  <a:rPr lang="en-US" dirty="0"/>
-                  <a:t>DAQ</a:t>
-                </a:r>
+                <a:endParaRPr lang="en-US" sz="1799">
+                  <a:solidFill>
+                    <a:schemeClr val="tx1"/>
+                  </a:solidFill>
+                </a:endParaRPr>
               </a:p>
             </p:txBody>
           </p:sp>
           <p:sp>
             <p:nvSpPr>
-              <p:cNvPr id="7" name="Rectangle 6">
+              <p:cNvPr id="17" name="Arrow: Curved Down 16">
                 <a:extLst>
                   <a:ext uri="{FF2B5EF4-FFF2-40B4-BE49-F238E27FC236}">
-                    <a16:creationId xmlns:a16="http://schemas.microsoft.com/office/drawing/2014/main" id="{FD4DC6E5-085E-29CE-AE3E-00A3DA69310A}"/>
+                    <a16:creationId xmlns:a16="http://schemas.microsoft.com/office/drawing/2014/main" id="{9811D107-CA7B-4579-4C79-056E819DB3EA}"/>
                   </a:ext>
                 </a:extLst>
               </p:cNvPr>
@@ -8478,34 +9185,24 @@
             </p:nvSpPr>
             <p:spPr>
               <a:xfrm>
-                <a:off x="1020836" y="907427"/>
-                <a:ext cx="781045" cy="3908417"/>
+                <a:off x="2911011" y="3912050"/>
+                <a:ext cx="1457325" cy="385765"/>
               </a:xfrm>
-              <a:prstGeom prst="rect">
+              <a:prstGeom prst="curvedDownArrow">
                 <a:avLst/>
               </a:prstGeom>
-              <a:solidFill>
-                <a:schemeClr val="bg1"/>
-              </a:solidFill>
-              <a:ln w="28575">
-                <a:solidFill>
-                  <a:schemeClr val="bg1">
-                    <a:lumMod val="50000"/>
-                  </a:schemeClr>
-                </a:solidFill>
-              </a:ln>
             </p:spPr>
             <p:style>
               <a:lnRef idx="2">
-                <a:schemeClr val="accent1">
+                <a:schemeClr val="accent6">
                   <a:shade val="15000"/>
                 </a:schemeClr>
               </a:lnRef>
               <a:fillRef idx="1">
-                <a:schemeClr val="accent1"/>
+                <a:schemeClr val="accent6"/>
               </a:fillRef>
               <a:effectRef idx="0">
-                <a:schemeClr val="accent1"/>
+                <a:schemeClr val="accent6"/>
               </a:effectRef>
               <a:fontRef idx="minor">
                 <a:schemeClr val="lt1"/>
@@ -8516,16 +9213,20 @@
               <a:lstStyle/>
               <a:p>
                 <a:pPr algn="ctr"/>
-                <a:endParaRPr lang="en-US"/>
+                <a:endParaRPr lang="en-US" sz="1799">
+                  <a:solidFill>
+                    <a:schemeClr val="tx1"/>
+                  </a:solidFill>
+                </a:endParaRPr>
               </a:p>
             </p:txBody>
           </p:sp>
           <p:sp>
             <p:nvSpPr>
-              <p:cNvPr id="8" name="Rectangle 7">
+              <p:cNvPr id="18" name="Arrow: Curved Down 17">
                 <a:extLst>
                   <a:ext uri="{FF2B5EF4-FFF2-40B4-BE49-F238E27FC236}">
-                    <a16:creationId xmlns:a16="http://schemas.microsoft.com/office/drawing/2014/main" id="{E5C75B8F-0D1B-D99E-328B-710285BFB2B9}"/>
+                    <a16:creationId xmlns:a16="http://schemas.microsoft.com/office/drawing/2014/main" id="{6CE41918-056B-D9D6-9698-49AF35AA2931}"/>
                   </a:ext>
                 </a:extLst>
               </p:cNvPr>
@@ -8534,34 +9235,24 @@
             </p:nvSpPr>
             <p:spPr>
               <a:xfrm>
-                <a:off x="5559497" y="969782"/>
-                <a:ext cx="781045" cy="3846060"/>
+                <a:off x="5221356" y="1996254"/>
+                <a:ext cx="1457325" cy="385765"/>
               </a:xfrm>
-              <a:prstGeom prst="rect">
+              <a:prstGeom prst="curvedDownArrow">
                 <a:avLst/>
               </a:prstGeom>
-              <a:solidFill>
-                <a:schemeClr val="bg1"/>
-              </a:solidFill>
-              <a:ln w="28575">
-                <a:solidFill>
-                  <a:schemeClr val="bg1">
-                    <a:lumMod val="50000"/>
-                  </a:schemeClr>
-                </a:solidFill>
-              </a:ln>
             </p:spPr>
             <p:style>
               <a:lnRef idx="2">
-                <a:schemeClr val="accent1">
+                <a:schemeClr val="accent6">
                   <a:shade val="15000"/>
                 </a:schemeClr>
               </a:lnRef>
               <a:fillRef idx="1">
-                <a:schemeClr val="accent1"/>
+                <a:schemeClr val="accent6"/>
               </a:fillRef>
               <a:effectRef idx="0">
-                <a:schemeClr val="accent1"/>
+                <a:schemeClr val="accent6"/>
               </a:effectRef>
               <a:fontRef idx="minor">
                 <a:schemeClr val="lt1"/>
@@ -8572,555 +9263,21 @@
               <a:lstStyle/>
               <a:p>
                 <a:pPr algn="ctr"/>
-                <a:endParaRPr lang="en-US"/>
-              </a:p>
-            </p:txBody>
-          </p:sp>
-          <p:sp>
-            <p:nvSpPr>
-              <p:cNvPr id="9" name="Trapezoid 8">
-                <a:extLst>
-                  <a:ext uri="{FF2B5EF4-FFF2-40B4-BE49-F238E27FC236}">
-                    <a16:creationId xmlns:a16="http://schemas.microsoft.com/office/drawing/2014/main" id="{5209F7CC-7B6D-B6A2-5705-4ECC1CE773EB}"/>
-                  </a:ext>
-                </a:extLst>
-              </p:cNvPr>
-              <p:cNvSpPr/>
-              <p:nvPr/>
-            </p:nvSpPr>
-            <p:spPr>
-              <a:xfrm flipH="1" flipV="1">
-                <a:off x="1225618" y="1591374"/>
-                <a:ext cx="409575" cy="2333622"/>
-              </a:xfrm>
-              <a:prstGeom prst="trapezoid">
-                <a:avLst/>
-              </a:prstGeom>
-              <a:solidFill>
-                <a:srgbClr val="C00000">
-                  <a:alpha val="50000"/>
-                </a:srgbClr>
-              </a:solidFill>
-              <a:ln>
-                <a:prstDash val="dash"/>
-              </a:ln>
-            </p:spPr>
-            <p:style>
-              <a:lnRef idx="2">
-                <a:schemeClr val="accent1">
-                  <a:shade val="15000"/>
-                </a:schemeClr>
-              </a:lnRef>
-              <a:fillRef idx="1">
-                <a:schemeClr val="accent1"/>
-              </a:fillRef>
-              <a:effectRef idx="0">
-                <a:schemeClr val="accent1"/>
-              </a:effectRef>
-              <a:fontRef idx="minor">
-                <a:schemeClr val="lt1"/>
-              </a:fontRef>
-            </p:style>
-            <p:txBody>
-              <a:bodyPr rtlCol="0" anchor="ctr"/>
-              <a:lstStyle/>
-              <a:p>
-                <a:pPr algn="ctr"/>
-                <a:endParaRPr lang="en-US"/>
-              </a:p>
-            </p:txBody>
-          </p:sp>
-          <p:cxnSp>
-            <p:nvCxnSpPr>
-              <p:cNvPr id="10" name="Straight Connector 9">
-                <a:extLst>
-                  <a:ext uri="{FF2B5EF4-FFF2-40B4-BE49-F238E27FC236}">
-                    <a16:creationId xmlns:a16="http://schemas.microsoft.com/office/drawing/2014/main" id="{2573B160-1E6A-F63D-5787-60E43AF7ECA8}"/>
-                  </a:ext>
-                </a:extLst>
-              </p:cNvPr>
-              <p:cNvCxnSpPr>
-                <a:cxnSpLocks/>
-              </p:cNvCxnSpPr>
-              <p:nvPr/>
-            </p:nvCxnSpPr>
-            <p:spPr>
-              <a:xfrm>
-                <a:off x="406471" y="1546046"/>
-                <a:ext cx="6572250" cy="0"/>
-              </a:xfrm>
-              <a:prstGeom prst="line">
-                <a:avLst/>
-              </a:prstGeom>
-              <a:ln w="38100"/>
-            </p:spPr>
-            <p:style>
-              <a:lnRef idx="2">
-                <a:schemeClr val="accent1"/>
-              </a:lnRef>
-              <a:fillRef idx="0">
-                <a:schemeClr val="accent1"/>
-              </a:fillRef>
-              <a:effectRef idx="1">
-                <a:schemeClr val="accent1"/>
-              </a:effectRef>
-              <a:fontRef idx="minor">
-                <a:schemeClr val="tx1"/>
-              </a:fontRef>
-            </p:style>
-          </p:cxnSp>
-          <p:sp>
-            <p:nvSpPr>
-              <p:cNvPr id="11" name="Trapezoid 10">
-                <a:extLst>
-                  <a:ext uri="{FF2B5EF4-FFF2-40B4-BE49-F238E27FC236}">
-                    <a16:creationId xmlns:a16="http://schemas.microsoft.com/office/drawing/2014/main" id="{C7E8DB78-4CB3-0532-2E8F-50BB26AFBE32}"/>
-                  </a:ext>
-                </a:extLst>
-              </p:cNvPr>
-              <p:cNvSpPr/>
-              <p:nvPr/>
-            </p:nvSpPr>
-            <p:spPr>
-              <a:xfrm flipH="1" flipV="1">
-                <a:off x="5764280" y="1591374"/>
-                <a:ext cx="409575" cy="2333622"/>
-              </a:xfrm>
-              <a:prstGeom prst="trapezoid">
-                <a:avLst/>
-              </a:prstGeom>
-              <a:solidFill>
-                <a:srgbClr val="C00000">
-                  <a:alpha val="50000"/>
-                </a:srgbClr>
-              </a:solidFill>
-              <a:ln>
-                <a:prstDash val="dash"/>
-              </a:ln>
-            </p:spPr>
-            <p:style>
-              <a:lnRef idx="2">
-                <a:schemeClr val="accent1">
-                  <a:shade val="15000"/>
-                </a:schemeClr>
-              </a:lnRef>
-              <a:fillRef idx="1">
-                <a:schemeClr val="accent1"/>
-              </a:fillRef>
-              <a:effectRef idx="0">
-                <a:schemeClr val="accent1"/>
-              </a:effectRef>
-              <a:fontRef idx="minor">
-                <a:schemeClr val="lt1"/>
-              </a:fontRef>
-            </p:style>
-            <p:txBody>
-              <a:bodyPr rtlCol="0" anchor="ctr"/>
-              <a:lstStyle/>
-              <a:p>
-                <a:pPr algn="ctr"/>
-                <a:endParaRPr lang="en-US"/>
-              </a:p>
-            </p:txBody>
-          </p:sp>
-          <p:sp>
-            <p:nvSpPr>
-              <p:cNvPr id="14" name="Rectangle 13">
-                <a:extLst>
-                  <a:ext uri="{FF2B5EF4-FFF2-40B4-BE49-F238E27FC236}">
-                    <a16:creationId xmlns:a16="http://schemas.microsoft.com/office/drawing/2014/main" id="{219292C3-AA67-23A6-9D74-BA36E788B344}"/>
-                  </a:ext>
-                </a:extLst>
-              </p:cNvPr>
-              <p:cNvSpPr/>
-              <p:nvPr/>
-            </p:nvSpPr>
-            <p:spPr>
-              <a:xfrm>
-                <a:off x="1439928" y="4131697"/>
-                <a:ext cx="4519615" cy="161924"/>
-              </a:xfrm>
-              <a:prstGeom prst="rect">
-                <a:avLst/>
-              </a:prstGeom>
-              <a:solidFill>
-                <a:schemeClr val="bg2">
-                  <a:lumMod val="75000"/>
-                </a:schemeClr>
-              </a:solidFill>
-            </p:spPr>
-            <p:style>
-              <a:lnRef idx="2">
-                <a:schemeClr val="accent1">
-                  <a:shade val="15000"/>
-                </a:schemeClr>
-              </a:lnRef>
-              <a:fillRef idx="1">
-                <a:schemeClr val="accent1"/>
-              </a:fillRef>
-              <a:effectRef idx="0">
-                <a:schemeClr val="accent1"/>
-              </a:effectRef>
-              <a:fontRef idx="minor">
-                <a:schemeClr val="lt1"/>
-              </a:fontRef>
-            </p:style>
-            <p:txBody>
-              <a:bodyPr rtlCol="0" anchor="ctr"/>
-              <a:lstStyle/>
-              <a:p>
-                <a:pPr algn="ctr"/>
-                <a:endParaRPr lang="en-US"/>
-              </a:p>
-            </p:txBody>
-          </p:sp>
-          <p:sp>
-            <p:nvSpPr>
-              <p:cNvPr id="38" name="Oval 37">
-                <a:extLst>
-                  <a:ext uri="{FF2B5EF4-FFF2-40B4-BE49-F238E27FC236}">
-                    <a16:creationId xmlns:a16="http://schemas.microsoft.com/office/drawing/2014/main" id="{0E438C7E-CB09-C37A-5C68-CAC643B84434}"/>
-                  </a:ext>
-                </a:extLst>
-              </p:cNvPr>
-              <p:cNvSpPr/>
-              <p:nvPr/>
-            </p:nvSpPr>
-            <p:spPr>
-              <a:xfrm>
-                <a:off x="1358967" y="2698265"/>
-                <a:ext cx="142875" cy="204788"/>
-              </a:xfrm>
-              <a:prstGeom prst="ellipse">
-                <a:avLst/>
-              </a:prstGeom>
-            </p:spPr>
-            <p:style>
-              <a:lnRef idx="2">
-                <a:schemeClr val="accent2">
-                  <a:shade val="15000"/>
-                </a:schemeClr>
-              </a:lnRef>
-              <a:fillRef idx="1">
-                <a:schemeClr val="accent2"/>
-              </a:fillRef>
-              <a:effectRef idx="0">
-                <a:schemeClr val="accent2"/>
-              </a:effectRef>
-              <a:fontRef idx="minor">
-                <a:schemeClr val="lt1"/>
-              </a:fontRef>
-            </p:style>
-            <p:txBody>
-              <a:bodyPr rtlCol="0" anchor="ctr"/>
-              <a:lstStyle/>
-              <a:p>
-                <a:pPr algn="ctr"/>
-                <a:endParaRPr lang="en-US"/>
-              </a:p>
-            </p:txBody>
-          </p:sp>
-          <p:sp>
-            <p:nvSpPr>
-              <p:cNvPr id="39" name="Oval 38">
-                <a:extLst>
-                  <a:ext uri="{FF2B5EF4-FFF2-40B4-BE49-F238E27FC236}">
-                    <a16:creationId xmlns:a16="http://schemas.microsoft.com/office/drawing/2014/main" id="{9A7AD91F-B085-5939-BC7E-0F12239F186C}"/>
-                  </a:ext>
-                </a:extLst>
-              </p:cNvPr>
-              <p:cNvSpPr/>
-              <p:nvPr/>
-            </p:nvSpPr>
-            <p:spPr>
-              <a:xfrm>
-                <a:off x="5897628" y="2702641"/>
-                <a:ext cx="142875" cy="204788"/>
-              </a:xfrm>
-              <a:prstGeom prst="ellipse">
-                <a:avLst/>
-              </a:prstGeom>
-            </p:spPr>
-            <p:style>
-              <a:lnRef idx="2">
-                <a:schemeClr val="accent2">
-                  <a:shade val="15000"/>
-                </a:schemeClr>
-              </a:lnRef>
-              <a:fillRef idx="1">
-                <a:schemeClr val="accent2"/>
-              </a:fillRef>
-              <a:effectRef idx="0">
-                <a:schemeClr val="accent2"/>
-              </a:effectRef>
-              <a:fontRef idx="minor">
-                <a:schemeClr val="lt1"/>
-              </a:fontRef>
-            </p:style>
-            <p:txBody>
-              <a:bodyPr rtlCol="0" anchor="ctr"/>
-              <a:lstStyle/>
-              <a:p>
-                <a:pPr algn="ctr"/>
-                <a:endParaRPr lang="en-US"/>
-              </a:p>
-            </p:txBody>
-          </p:sp>
-          <p:sp>
-            <p:nvSpPr>
-              <p:cNvPr id="54" name="TextBox 53">
-                <a:extLst>
-                  <a:ext uri="{FF2B5EF4-FFF2-40B4-BE49-F238E27FC236}">
-                    <a16:creationId xmlns:a16="http://schemas.microsoft.com/office/drawing/2014/main" id="{1E04B801-D17B-DEFC-0687-7CBD3A848CCB}"/>
-                  </a:ext>
-                </a:extLst>
-              </p:cNvPr>
-              <p:cNvSpPr txBox="1"/>
-              <p:nvPr/>
-            </p:nvSpPr>
-            <p:spPr>
-              <a:xfrm>
-                <a:off x="2662908" y="4027993"/>
-                <a:ext cx="1921264" cy="369332"/>
-              </a:xfrm>
-              <a:prstGeom prst="rect">
-                <a:avLst/>
-              </a:prstGeom>
-              <a:noFill/>
-            </p:spPr>
-            <p:txBody>
-              <a:bodyPr wrap="square" rtlCol="0">
-                <a:spAutoFit/>
-              </a:bodyPr>
-              <a:lstStyle/>
-              <a:p>
-                <a:pPr algn="ctr"/>
-                <a:r>
-                  <a:rPr lang="en-US" dirty="0"/>
-                  <a:t>Platform</a:t>
-                </a:r>
-              </a:p>
-            </p:txBody>
-          </p:sp>
-          <p:sp>
-            <p:nvSpPr>
-              <p:cNvPr id="62" name="TextBox 61">
-                <a:extLst>
-                  <a:ext uri="{FF2B5EF4-FFF2-40B4-BE49-F238E27FC236}">
-                    <a16:creationId xmlns:a16="http://schemas.microsoft.com/office/drawing/2014/main" id="{C06D07EC-6425-2466-9E94-B68138DBAE7D}"/>
-                  </a:ext>
-                </a:extLst>
-              </p:cNvPr>
-              <p:cNvSpPr txBox="1"/>
-              <p:nvPr/>
-            </p:nvSpPr>
-            <p:spPr>
-              <a:xfrm>
-                <a:off x="1928151" y="2284874"/>
-                <a:ext cx="781045" cy="369332"/>
-              </a:xfrm>
-              <a:prstGeom prst="rect">
-                <a:avLst/>
-              </a:prstGeom>
-              <a:noFill/>
-            </p:spPr>
-            <p:txBody>
-              <a:bodyPr wrap="square" rtlCol="0">
-                <a:spAutoFit/>
-              </a:bodyPr>
-              <a:lstStyle/>
-              <a:p>
-                <a:r>
-                  <a:rPr lang="en-US" dirty="0"/>
-                  <a:t>1 </a:t>
-                </a:r>
-                <a:r>
-                  <a:rPr lang="en-US" dirty="0" err="1"/>
-                  <a:t>dof</a:t>
-                </a:r>
-                <a:endParaRPr lang="en-US" dirty="0"/>
-              </a:p>
-            </p:txBody>
-          </p:sp>
-          <p:sp>
-            <p:nvSpPr>
-              <p:cNvPr id="63" name="TextBox 62">
-                <a:extLst>
-                  <a:ext uri="{FF2B5EF4-FFF2-40B4-BE49-F238E27FC236}">
-                    <a16:creationId xmlns:a16="http://schemas.microsoft.com/office/drawing/2014/main" id="{E0F00F77-2C38-E382-E64B-EFD30C890F64}"/>
-                  </a:ext>
-                </a:extLst>
-              </p:cNvPr>
-              <p:cNvSpPr txBox="1"/>
-              <p:nvPr/>
-            </p:nvSpPr>
-            <p:spPr>
-              <a:xfrm>
-                <a:off x="3839699" y="3605131"/>
-                <a:ext cx="781045" cy="369332"/>
-              </a:xfrm>
-              <a:prstGeom prst="rect">
-                <a:avLst/>
-              </a:prstGeom>
-              <a:noFill/>
-            </p:spPr>
-            <p:txBody>
-              <a:bodyPr wrap="square" rtlCol="0">
-                <a:spAutoFit/>
-              </a:bodyPr>
-              <a:lstStyle/>
-              <a:p>
-                <a:r>
-                  <a:rPr lang="en-US" dirty="0"/>
-                  <a:t>3 </a:t>
-                </a:r>
-                <a:r>
-                  <a:rPr lang="en-US" dirty="0" err="1"/>
-                  <a:t>dof</a:t>
-                </a:r>
-                <a:endParaRPr lang="en-US" dirty="0"/>
-              </a:p>
-            </p:txBody>
-          </p:sp>
-          <p:sp>
-            <p:nvSpPr>
-              <p:cNvPr id="64" name="TextBox 63">
-                <a:extLst>
-                  <a:ext uri="{FF2B5EF4-FFF2-40B4-BE49-F238E27FC236}">
-                    <a16:creationId xmlns:a16="http://schemas.microsoft.com/office/drawing/2014/main" id="{0FD595FC-2231-FEC6-A71B-AA289363B104}"/>
-                  </a:ext>
-                </a:extLst>
-              </p:cNvPr>
-              <p:cNvSpPr txBox="1"/>
-              <p:nvPr/>
-            </p:nvSpPr>
-            <p:spPr>
-              <a:xfrm>
-                <a:off x="6488185" y="2401363"/>
-                <a:ext cx="781045" cy="369332"/>
-              </a:xfrm>
-              <a:prstGeom prst="rect">
-                <a:avLst/>
-              </a:prstGeom>
-              <a:noFill/>
-            </p:spPr>
-            <p:txBody>
-              <a:bodyPr wrap="square" rtlCol="0">
-                <a:spAutoFit/>
-              </a:bodyPr>
-              <a:lstStyle/>
-              <a:p>
-                <a:r>
-                  <a:rPr lang="en-US" dirty="0"/>
-                  <a:t>1 </a:t>
-                </a:r>
-                <a:r>
-                  <a:rPr lang="en-US" dirty="0" err="1"/>
-                  <a:t>dof</a:t>
-                </a:r>
-                <a:endParaRPr lang="en-US" dirty="0"/>
+                <a:endParaRPr lang="en-US" sz="1799">
+                  <a:solidFill>
+                    <a:schemeClr val="tx1"/>
+                  </a:solidFill>
+                </a:endParaRPr>
               </a:p>
             </p:txBody>
           </p:sp>
         </p:grpSp>
-        <p:cxnSp>
-          <p:nvCxnSpPr>
-            <p:cNvPr id="12" name="Straight Arrow Connector 11">
-              <a:extLst>
-                <a:ext uri="{FF2B5EF4-FFF2-40B4-BE49-F238E27FC236}">
-                  <a16:creationId xmlns:a16="http://schemas.microsoft.com/office/drawing/2014/main" id="{FBD39DDA-34EC-AFAA-5CE8-C5F3F2614B26}"/>
-                </a:ext>
-              </a:extLst>
-            </p:cNvPr>
-            <p:cNvCxnSpPr/>
-            <p:nvPr/>
-          </p:nvCxnSpPr>
-          <p:spPr>
-            <a:xfrm>
-              <a:off x="3626777" y="3603757"/>
-              <a:ext cx="0" cy="1479479"/>
-            </a:xfrm>
-            <a:prstGeom prst="straightConnector1">
-              <a:avLst/>
-            </a:prstGeom>
-            <a:ln w="38100">
-              <a:solidFill>
-                <a:schemeClr val="accent6">
-                  <a:lumMod val="75000"/>
-                </a:schemeClr>
-              </a:solidFill>
-              <a:headEnd type="triangle"/>
-              <a:tailEnd type="triangle"/>
-            </a:ln>
-          </p:spPr>
-          <p:style>
-            <a:lnRef idx="2">
-              <a:schemeClr val="dk1"/>
-            </a:lnRef>
-            <a:fillRef idx="0">
-              <a:schemeClr val="dk1"/>
-            </a:fillRef>
-            <a:effectRef idx="1">
-              <a:schemeClr val="dk1"/>
-            </a:effectRef>
-            <a:fontRef idx="minor">
-              <a:schemeClr val="tx1"/>
-            </a:fontRef>
-          </p:style>
-        </p:cxnSp>
-        <p:cxnSp>
-          <p:nvCxnSpPr>
-            <p:cNvPr id="13" name="Straight Arrow Connector 12">
-              <a:extLst>
-                <a:ext uri="{FF2B5EF4-FFF2-40B4-BE49-F238E27FC236}">
-                  <a16:creationId xmlns:a16="http://schemas.microsoft.com/office/drawing/2014/main" id="{85DEEC32-100E-F1FC-19C0-CEDDEEE3184D}"/>
-                </a:ext>
-              </a:extLst>
-            </p:cNvPr>
-            <p:cNvCxnSpPr>
-              <a:cxnSpLocks/>
-            </p:cNvCxnSpPr>
-            <p:nvPr/>
-          </p:nvCxnSpPr>
-          <p:spPr>
-            <a:xfrm>
-              <a:off x="2764604" y="4099162"/>
-              <a:ext cx="1724346" cy="0"/>
-            </a:xfrm>
-            <a:prstGeom prst="straightConnector1">
-              <a:avLst/>
-            </a:prstGeom>
-            <a:ln w="38100">
-              <a:solidFill>
-                <a:schemeClr val="accent6">
-                  <a:lumMod val="75000"/>
-                </a:schemeClr>
-              </a:solidFill>
-              <a:headEnd type="triangle"/>
-              <a:tailEnd type="triangle"/>
-            </a:ln>
-          </p:spPr>
-          <p:style>
-            <a:lnRef idx="2">
-              <a:schemeClr val="dk1"/>
-            </a:lnRef>
-            <a:fillRef idx="0">
-              <a:schemeClr val="dk1"/>
-            </a:fillRef>
-            <a:effectRef idx="1">
-              <a:schemeClr val="dk1"/>
-            </a:effectRef>
-            <a:fontRef idx="minor">
-              <a:schemeClr val="tx1"/>
-            </a:fontRef>
-          </p:style>
-        </p:cxnSp>
         <p:sp>
           <p:nvSpPr>
-            <p:cNvPr id="16" name="Arrow: Curved Down 15">
-              <a:extLst>
-                <a:ext uri="{FF2B5EF4-FFF2-40B4-BE49-F238E27FC236}">
-                  <a16:creationId xmlns:a16="http://schemas.microsoft.com/office/drawing/2014/main" id="{A9B4A184-71D4-CCBD-5018-EE022E130B22}"/>
+            <p:cNvPr id="2" name="Oval 1">
+              <a:extLst>
+                <a:ext uri="{FF2B5EF4-FFF2-40B4-BE49-F238E27FC236}">
+                  <a16:creationId xmlns:a16="http://schemas.microsoft.com/office/drawing/2014/main" id="{F0C04D39-1EF8-0E0A-C30D-77E5EBCAC580}"/>
                 </a:ext>
               </a:extLst>
             </p:cNvPr>
@@ -9129,10 +9286,10 @@
           </p:nvSpPr>
           <p:spPr>
             <a:xfrm>
-              <a:off x="682695" y="1929428"/>
-              <a:ext cx="1457325" cy="385765"/>
-            </a:xfrm>
-            <a:prstGeom prst="curvedDownArrow">
+              <a:off x="1346489" y="3861094"/>
+              <a:ext cx="158145" cy="161924"/>
+            </a:xfrm>
+            <a:prstGeom prst="ellipse">
               <a:avLst/>
             </a:prstGeom>
           </p:spPr>
@@ -9157,20 +9314,16 @@
             <a:lstStyle/>
             <a:p>
               <a:pPr algn="ctr"/>
-              <a:endParaRPr lang="en-US">
-                <a:solidFill>
-                  <a:schemeClr val="tx1"/>
-                </a:solidFill>
-              </a:endParaRPr>
+              <a:endParaRPr lang="en-US" sz="1799"/>
             </a:p>
           </p:txBody>
         </p:sp>
         <p:sp>
           <p:nvSpPr>
-            <p:cNvPr id="17" name="Arrow: Curved Down 16">
-              <a:extLst>
-                <a:ext uri="{FF2B5EF4-FFF2-40B4-BE49-F238E27FC236}">
-                  <a16:creationId xmlns:a16="http://schemas.microsoft.com/office/drawing/2014/main" id="{9811D107-CA7B-4579-4C79-056E819DB3EA}"/>
+            <p:cNvPr id="3" name="Oval 2">
+              <a:extLst>
+                <a:ext uri="{FF2B5EF4-FFF2-40B4-BE49-F238E27FC236}">
+                  <a16:creationId xmlns:a16="http://schemas.microsoft.com/office/drawing/2014/main" id="{B4A8B97E-E3E1-A0AF-702C-62DC98EEDE30}"/>
                 </a:ext>
               </a:extLst>
             </p:cNvPr>
@@ -9179,10 +9332,10 @@
           </p:nvSpPr>
           <p:spPr>
             <a:xfrm>
-              <a:off x="2911011" y="3912050"/>
-              <a:ext cx="1457325" cy="385765"/>
-            </a:xfrm>
-            <a:prstGeom prst="curvedDownArrow">
+              <a:off x="5882358" y="3842421"/>
+              <a:ext cx="158145" cy="161924"/>
+            </a:xfrm>
+            <a:prstGeom prst="ellipse">
               <a:avLst/>
             </a:prstGeom>
           </p:spPr>
@@ -9207,20 +9360,665 @@
             <a:lstStyle/>
             <a:p>
               <a:pPr algn="ctr"/>
-              <a:endParaRPr lang="en-US">
+              <a:endParaRPr lang="en-US" sz="1799"/>
+            </a:p>
+          </p:txBody>
+        </p:sp>
+        <p:sp>
+          <p:nvSpPr>
+            <p:cNvPr id="4" name="TextBox 3">
+              <a:extLst>
+                <a:ext uri="{FF2B5EF4-FFF2-40B4-BE49-F238E27FC236}">
+                  <a16:creationId xmlns:a16="http://schemas.microsoft.com/office/drawing/2014/main" id="{E6930ED3-D4FE-3944-BDF0-FFF89A46549A}"/>
+                </a:ext>
+              </a:extLst>
+            </p:cNvPr>
+            <p:cNvSpPr txBox="1"/>
+            <p:nvPr/>
+          </p:nvSpPr>
+          <p:spPr>
+            <a:xfrm>
+              <a:off x="1791565" y="1200432"/>
+              <a:ext cx="1921264" cy="369204"/>
+            </a:xfrm>
+            <a:prstGeom prst="rect">
+              <a:avLst/>
+            </a:prstGeom>
+            <a:noFill/>
+          </p:spPr>
+          <p:txBody>
+            <a:bodyPr wrap="square" rtlCol="0">
+              <a:spAutoFit/>
+            </a:bodyPr>
+            <a:lstStyle/>
+            <a:p>
+              <a:r>
+                <a:rPr lang="en-US" sz="1799" dirty="0"/>
+                <a:t>still water line</a:t>
+              </a:r>
+            </a:p>
+          </p:txBody>
+        </p:sp>
+      </p:grpSp>
+    </p:spTree>
+    <p:extLst>
+      <p:ext uri="{BB962C8B-B14F-4D97-AF65-F5344CB8AC3E}">
+        <p14:creationId xmlns:p14="http://schemas.microsoft.com/office/powerpoint/2010/main" val="103456040"/>
+      </p:ext>
+    </p:extLst>
+  </p:cSld>
+  <p:clrMapOvr>
+    <a:masterClrMapping/>
+  </p:clrMapOvr>
+</p:sld>
+</file>
+
+<file path=ppt/slides/slide5.xml><?xml version="1.0" encoding="utf-8"?>
+<p:sld xmlns:a="http://schemas.openxmlformats.org/drawingml/2006/main" xmlns:r="http://schemas.openxmlformats.org/officeDocument/2006/relationships" xmlns:p="http://schemas.openxmlformats.org/presentationml/2006/main">
+  <p:cSld>
+    <p:spTree>
+      <p:nvGrpSpPr>
+        <p:cNvPr id="1" name=""/>
+        <p:cNvGrpSpPr/>
+        <p:nvPr/>
+      </p:nvGrpSpPr>
+      <p:grpSpPr>
+        <a:xfrm>
+          <a:off x="0" y="0"/>
+          <a:ext cx="0" cy="0"/>
+          <a:chOff x="0" y="0"/>
+          <a:chExt cx="0" cy="0"/>
+        </a:xfrm>
+      </p:grpSpPr>
+      <p:grpSp>
+        <p:nvGrpSpPr>
+          <p:cNvPr id="26" name="Group 25">
+            <a:extLst>
+              <a:ext uri="{FF2B5EF4-FFF2-40B4-BE49-F238E27FC236}">
+                <a16:creationId xmlns:a16="http://schemas.microsoft.com/office/drawing/2014/main" id="{98C5269E-30FE-1E3C-C84B-0021ADCB83C4}"/>
+              </a:ext>
+            </a:extLst>
+          </p:cNvPr>
+          <p:cNvGrpSpPr/>
+          <p:nvPr/>
+        </p:nvGrpSpPr>
+        <p:grpSpPr>
+          <a:xfrm>
+            <a:off x="795002" y="925149"/>
+            <a:ext cx="3184985" cy="2742993"/>
+            <a:chOff x="4134103" y="1182003"/>
+            <a:chExt cx="3184985" cy="2742993"/>
+          </a:xfrm>
+        </p:grpSpPr>
+        <p:sp>
+          <p:nvSpPr>
+            <p:cNvPr id="4" name="Trapezoid 3">
+              <a:extLst>
+                <a:ext uri="{FF2B5EF4-FFF2-40B4-BE49-F238E27FC236}">
+                  <a16:creationId xmlns:a16="http://schemas.microsoft.com/office/drawing/2014/main" id="{182174C3-1C95-69B3-EE75-15CC917966BA}"/>
+                </a:ext>
+              </a:extLst>
+            </p:cNvPr>
+            <p:cNvSpPr/>
+            <p:nvPr/>
+          </p:nvSpPr>
+          <p:spPr>
+            <a:xfrm rot="1529856" flipH="1" flipV="1">
+              <a:off x="5764282" y="1591373"/>
+              <a:ext cx="409575" cy="2333623"/>
+            </a:xfrm>
+            <a:prstGeom prst="trapezoid">
+              <a:avLst/>
+            </a:prstGeom>
+            <a:solidFill>
+              <a:srgbClr val="C00000">
+                <a:alpha val="50000"/>
+              </a:srgbClr>
+            </a:solidFill>
+            <a:ln>
+              <a:prstDash val="dash"/>
+            </a:ln>
+          </p:spPr>
+          <p:style>
+            <a:lnRef idx="2">
+              <a:schemeClr val="accent1">
+                <a:shade val="15000"/>
+              </a:schemeClr>
+            </a:lnRef>
+            <a:fillRef idx="1">
+              <a:schemeClr val="accent1"/>
+            </a:fillRef>
+            <a:effectRef idx="0">
+              <a:schemeClr val="accent1"/>
+            </a:effectRef>
+            <a:fontRef idx="minor">
+              <a:schemeClr val="lt1"/>
+            </a:fontRef>
+          </p:style>
+          <p:txBody>
+            <a:bodyPr rtlCol="0" anchor="ctr"/>
+            <a:lstStyle/>
+            <a:p>
+              <a:pPr algn="ctr"/>
+              <a:endParaRPr lang="en-US" sz="1799"/>
+            </a:p>
+          </p:txBody>
+        </p:sp>
+        <p:sp>
+          <p:nvSpPr>
+            <p:cNvPr id="5" name="Oval 4">
+              <a:extLst>
+                <a:ext uri="{FF2B5EF4-FFF2-40B4-BE49-F238E27FC236}">
+                  <a16:creationId xmlns:a16="http://schemas.microsoft.com/office/drawing/2014/main" id="{A9B8EE61-0FB4-EF48-B5F2-8B059D06AA28}"/>
+                </a:ext>
+              </a:extLst>
+            </p:cNvPr>
+            <p:cNvSpPr/>
+            <p:nvPr/>
+          </p:nvSpPr>
+          <p:spPr>
+            <a:xfrm rot="1529856">
+              <a:off x="5897630" y="2702641"/>
+              <a:ext cx="142875" cy="204788"/>
+            </a:xfrm>
+            <a:prstGeom prst="ellipse">
+              <a:avLst/>
+            </a:prstGeom>
+          </p:spPr>
+          <p:style>
+            <a:lnRef idx="2">
+              <a:schemeClr val="accent2">
+                <a:shade val="15000"/>
+              </a:schemeClr>
+            </a:lnRef>
+            <a:fillRef idx="1">
+              <a:schemeClr val="accent2"/>
+            </a:fillRef>
+            <a:effectRef idx="0">
+              <a:schemeClr val="accent2"/>
+            </a:effectRef>
+            <a:fontRef idx="minor">
+              <a:schemeClr val="lt1"/>
+            </a:fontRef>
+          </p:style>
+          <p:txBody>
+            <a:bodyPr rtlCol="0" anchor="ctr"/>
+            <a:lstStyle/>
+            <a:p>
+              <a:pPr algn="ctr"/>
+              <a:endParaRPr lang="en-US" sz="1799"/>
+            </a:p>
+          </p:txBody>
+        </p:sp>
+        <p:sp>
+          <p:nvSpPr>
+            <p:cNvPr id="6" name="TextBox 5">
+              <a:extLst>
+                <a:ext uri="{FF2B5EF4-FFF2-40B4-BE49-F238E27FC236}">
+                  <a16:creationId xmlns:a16="http://schemas.microsoft.com/office/drawing/2014/main" id="{364F4829-0DB8-8929-FE26-046AC0321830}"/>
+                </a:ext>
+              </a:extLst>
+            </p:cNvPr>
+            <p:cNvSpPr txBox="1"/>
+            <p:nvPr/>
+          </p:nvSpPr>
+          <p:spPr>
+            <a:xfrm>
+              <a:off x="6055367" y="2632314"/>
+              <a:ext cx="1263721" cy="369332"/>
+            </a:xfrm>
+            <a:prstGeom prst="rect">
+              <a:avLst/>
+            </a:prstGeom>
+            <a:noFill/>
+          </p:spPr>
+          <p:txBody>
+            <a:bodyPr wrap="square" rtlCol="0">
+              <a:spAutoFit/>
+            </a:bodyPr>
+            <a:lstStyle/>
+            <a:p>
+              <a:r>
+                <a:rPr lang="en-US" dirty="0">
+                  <a:solidFill>
+                    <a:schemeClr val="accent2"/>
+                  </a:solidFill>
+                </a:rPr>
+                <a:t>cg</a:t>
+              </a:r>
+            </a:p>
+          </p:txBody>
+        </p:sp>
+        <p:sp>
+          <p:nvSpPr>
+            <p:cNvPr id="7" name="Oval 6">
+              <a:extLst>
+                <a:ext uri="{FF2B5EF4-FFF2-40B4-BE49-F238E27FC236}">
+                  <a16:creationId xmlns:a16="http://schemas.microsoft.com/office/drawing/2014/main" id="{2DF5FC42-ADE0-CD0E-CCA9-72E9090B29BB}"/>
+                </a:ext>
+              </a:extLst>
+            </p:cNvPr>
+            <p:cNvSpPr/>
+            <p:nvPr/>
+          </p:nvSpPr>
+          <p:spPr>
+            <a:xfrm>
+              <a:off x="5923401" y="2384743"/>
+              <a:ext cx="172599" cy="224282"/>
+            </a:xfrm>
+            <a:prstGeom prst="ellipse">
+              <a:avLst/>
+            </a:prstGeom>
+          </p:spPr>
+          <p:style>
+            <a:lnRef idx="2">
+              <a:schemeClr val="accent1">
+                <a:shade val="15000"/>
+              </a:schemeClr>
+            </a:lnRef>
+            <a:fillRef idx="1">
+              <a:schemeClr val="accent1"/>
+            </a:fillRef>
+            <a:effectRef idx="0">
+              <a:schemeClr val="accent1"/>
+            </a:effectRef>
+            <a:fontRef idx="minor">
+              <a:schemeClr val="lt1"/>
+            </a:fontRef>
+          </p:style>
+          <p:txBody>
+            <a:bodyPr rtlCol="0" anchor="ctr"/>
+            <a:lstStyle/>
+            <a:p>
+              <a:pPr algn="ctr"/>
+              <a:endParaRPr lang="en-US"/>
+            </a:p>
+          </p:txBody>
+        </p:sp>
+        <p:sp>
+          <p:nvSpPr>
+            <p:cNvPr id="8" name="TextBox 7">
+              <a:extLst>
+                <a:ext uri="{FF2B5EF4-FFF2-40B4-BE49-F238E27FC236}">
+                  <a16:creationId xmlns:a16="http://schemas.microsoft.com/office/drawing/2014/main" id="{25AD6D48-0158-A750-8A81-295980FE0AB9}"/>
+                </a:ext>
+              </a:extLst>
+            </p:cNvPr>
+            <p:cNvSpPr txBox="1"/>
+            <p:nvPr/>
+          </p:nvSpPr>
+          <p:spPr>
+            <a:xfrm>
+              <a:off x="5464139" y="2293272"/>
+              <a:ext cx="1263721" cy="369332"/>
+            </a:xfrm>
+            <a:prstGeom prst="rect">
+              <a:avLst/>
+            </a:prstGeom>
+            <a:noFill/>
+          </p:spPr>
+          <p:txBody>
+            <a:bodyPr wrap="square" rtlCol="0">
+              <a:spAutoFit/>
+            </a:bodyPr>
+            <a:lstStyle/>
+            <a:p>
+              <a:r>
+                <a:rPr lang="en-US" dirty="0" err="1">
+                  <a:solidFill>
+                    <a:schemeClr val="accent1"/>
+                  </a:solidFill>
+                </a:rPr>
+                <a:t>cb</a:t>
+              </a:r>
+              <a:endParaRPr lang="en-US" dirty="0">
                 <a:solidFill>
-                  <a:schemeClr val="tx1"/>
+                  <a:schemeClr val="accent1"/>
                 </a:solidFill>
               </a:endParaRPr>
             </a:p>
           </p:txBody>
         </p:sp>
+        <p:cxnSp>
+          <p:nvCxnSpPr>
+            <p:cNvPr id="10" name="Straight Arrow Connector 9">
+              <a:extLst>
+                <a:ext uri="{FF2B5EF4-FFF2-40B4-BE49-F238E27FC236}">
+                  <a16:creationId xmlns:a16="http://schemas.microsoft.com/office/drawing/2014/main" id="{54B1144C-1EBE-1390-E271-43319200DF68}"/>
+                </a:ext>
+              </a:extLst>
+            </p:cNvPr>
+            <p:cNvCxnSpPr/>
+            <p:nvPr/>
+          </p:nvCxnSpPr>
+          <p:spPr>
+            <a:xfrm flipV="1">
+              <a:off x="6009700" y="1756881"/>
+              <a:ext cx="0" cy="740003"/>
+            </a:xfrm>
+            <a:prstGeom prst="straightConnector1">
+              <a:avLst/>
+            </a:prstGeom>
+            <a:ln w="38100">
+              <a:tailEnd type="triangle"/>
+            </a:ln>
+          </p:spPr>
+          <p:style>
+            <a:lnRef idx="2">
+              <a:schemeClr val="accent1"/>
+            </a:lnRef>
+            <a:fillRef idx="0">
+              <a:schemeClr val="accent1"/>
+            </a:fillRef>
+            <a:effectRef idx="1">
+              <a:schemeClr val="accent1"/>
+            </a:effectRef>
+            <a:fontRef idx="minor">
+              <a:schemeClr val="tx1"/>
+            </a:fontRef>
+          </p:style>
+        </p:cxnSp>
+        <p:cxnSp>
+          <p:nvCxnSpPr>
+            <p:cNvPr id="11" name="Straight Arrow Connector 10">
+              <a:extLst>
+                <a:ext uri="{FF2B5EF4-FFF2-40B4-BE49-F238E27FC236}">
+                  <a16:creationId xmlns:a16="http://schemas.microsoft.com/office/drawing/2014/main" id="{D76DEE71-0DFA-AB37-FFCE-9DACE54C5C2D}"/>
+                </a:ext>
+              </a:extLst>
+            </p:cNvPr>
+            <p:cNvCxnSpPr>
+              <a:cxnSpLocks/>
+            </p:cNvCxnSpPr>
+            <p:nvPr/>
+          </p:nvCxnSpPr>
+          <p:spPr>
+            <a:xfrm>
+              <a:off x="5969067" y="2805035"/>
+              <a:ext cx="0" cy="767886"/>
+            </a:xfrm>
+            <a:prstGeom prst="straightConnector1">
+              <a:avLst/>
+            </a:prstGeom>
+            <a:ln w="38100">
+              <a:tailEnd type="triangle"/>
+            </a:ln>
+          </p:spPr>
+          <p:style>
+            <a:lnRef idx="2">
+              <a:schemeClr val="accent2"/>
+            </a:lnRef>
+            <a:fillRef idx="0">
+              <a:schemeClr val="accent2"/>
+            </a:fillRef>
+            <a:effectRef idx="1">
+              <a:schemeClr val="accent2"/>
+            </a:effectRef>
+            <a:fontRef idx="minor">
+              <a:schemeClr val="tx1"/>
+            </a:fontRef>
+          </p:style>
+        </p:cxnSp>
+        <mc:AlternateContent xmlns:mc="http://schemas.openxmlformats.org/markup-compatibility/2006">
+          <mc:Choice xmlns:a14="http://schemas.microsoft.com/office/drawing/2010/main" Requires="a14">
+            <p:sp>
+              <p:nvSpPr>
+                <p:cNvPr id="14" name="TextBox 13">
+                  <a:extLst>
+                    <a:ext uri="{FF2B5EF4-FFF2-40B4-BE49-F238E27FC236}">
+                      <a16:creationId xmlns:a16="http://schemas.microsoft.com/office/drawing/2014/main" id="{825950A9-66B5-A6A3-A557-172EA652847E}"/>
+                    </a:ext>
+                  </a:extLst>
+                </p:cNvPr>
+                <p:cNvSpPr txBox="1"/>
+                <p:nvPr/>
+              </p:nvSpPr>
+              <p:spPr>
+                <a:xfrm>
+                  <a:off x="5591073" y="3037098"/>
+                  <a:ext cx="1263721" cy="391902"/>
+                </a:xfrm>
+                <a:prstGeom prst="rect">
+                  <a:avLst/>
+                </a:prstGeom>
+                <a:noFill/>
+              </p:spPr>
+              <p:txBody>
+                <a:bodyPr wrap="square" rtlCol="0">
+                  <a:spAutoFit/>
+                </a:bodyPr>
+                <a:lstStyle/>
+                <a:p>
+                  <a14:m>
+                    <m:oMathPara xmlns:m="http://schemas.openxmlformats.org/officeDocument/2006/math">
+                      <m:oMathParaPr>
+                        <m:jc m:val="centerGroup"/>
+                      </m:oMathParaPr>
+                      <m:oMath xmlns:m="http://schemas.openxmlformats.org/officeDocument/2006/math">
+                        <m:sSub>
+                          <m:sSubPr>
+                            <m:ctrlPr>
+                              <a:rPr lang="en-US" b="0" i="1" dirty="0" smtClean="0">
+                                <a:solidFill>
+                                  <a:schemeClr val="accent2"/>
+                                </a:solidFill>
+                                <a:latin typeface="Cambria Math" panose="02040503050406030204" pitchFamily="18" charset="0"/>
+                              </a:rPr>
+                            </m:ctrlPr>
+                          </m:sSubPr>
+                          <m:e>
+                            <m:r>
+                              <a:rPr lang="en-US" b="0" i="1" dirty="0" smtClean="0">
+                                <a:solidFill>
+                                  <a:schemeClr val="accent2"/>
+                                </a:solidFill>
+                                <a:latin typeface="Cambria Math" panose="02040503050406030204" pitchFamily="18" charset="0"/>
+                              </a:rPr>
+                              <m:t>𝐹</m:t>
+                            </m:r>
+                          </m:e>
+                          <m:sub>
+                            <m:r>
+                              <a:rPr lang="en-US" b="0" i="1" dirty="0" smtClean="0">
+                                <a:solidFill>
+                                  <a:schemeClr val="accent2"/>
+                                </a:solidFill>
+                                <a:latin typeface="Cambria Math" panose="02040503050406030204" pitchFamily="18" charset="0"/>
+                              </a:rPr>
+                              <m:t>𝑔</m:t>
+                            </m:r>
+                          </m:sub>
+                        </m:sSub>
+                      </m:oMath>
+                    </m:oMathPara>
+                  </a14:m>
+                  <a:endParaRPr lang="en-US" b="0" dirty="0">
+                    <a:solidFill>
+                      <a:schemeClr val="accent2"/>
+                    </a:solidFill>
+                  </a:endParaRPr>
+                </a:p>
+              </p:txBody>
+            </p:sp>
+          </mc:Choice>
+          <mc:Fallback>
+            <p:sp>
+              <p:nvSpPr>
+                <p:cNvPr id="14" name="TextBox 13">
+                  <a:extLst>
+                    <a:ext uri="{FF2B5EF4-FFF2-40B4-BE49-F238E27FC236}">
+                      <a16:creationId xmlns:a16="http://schemas.microsoft.com/office/drawing/2014/main" id="{825950A9-66B5-A6A3-A557-172EA652847E}"/>
+                    </a:ext>
+                  </a:extLst>
+                </p:cNvPr>
+                <p:cNvSpPr txBox="1">
+                  <a:spLocks noRot="1" noChangeAspect="1" noMove="1" noResize="1" noEditPoints="1" noAdjustHandles="1" noChangeArrowheads="1" noChangeShapeType="1" noTextEdit="1"/>
+                </p:cNvSpPr>
+                <p:nvPr/>
+              </p:nvSpPr>
+              <p:spPr>
+                <a:xfrm>
+                  <a:off x="5591073" y="3037098"/>
+                  <a:ext cx="1263721" cy="391902"/>
+                </a:xfrm>
+                <a:prstGeom prst="rect">
+                  <a:avLst/>
+                </a:prstGeom>
+                <a:blipFill>
+                  <a:blip r:embed="rId2"/>
+                  <a:stretch>
+                    <a:fillRect b="-6250"/>
+                  </a:stretch>
+                </a:blipFill>
+              </p:spPr>
+              <p:txBody>
+                <a:bodyPr/>
+                <a:lstStyle/>
+                <a:p>
+                  <a:r>
+                    <a:rPr lang="en-US">
+                      <a:noFill/>
+                    </a:rPr>
+                    <a:t> </a:t>
+                  </a:r>
+                </a:p>
+              </p:txBody>
+            </p:sp>
+          </mc:Fallback>
+        </mc:AlternateContent>
+        <mc:AlternateContent xmlns:mc="http://schemas.openxmlformats.org/markup-compatibility/2006">
+          <mc:Choice xmlns:a14="http://schemas.microsoft.com/office/drawing/2010/main" Requires="a14">
+            <p:sp>
+              <p:nvSpPr>
+                <p:cNvPr id="15" name="TextBox 14">
+                  <a:extLst>
+                    <a:ext uri="{FF2B5EF4-FFF2-40B4-BE49-F238E27FC236}">
+                      <a16:creationId xmlns:a16="http://schemas.microsoft.com/office/drawing/2014/main" id="{1BA5C519-A6F3-32B2-DE72-A19B249A3039}"/>
+                    </a:ext>
+                  </a:extLst>
+                </p:cNvPr>
+                <p:cNvSpPr txBox="1"/>
+                <p:nvPr/>
+              </p:nvSpPr>
+              <p:spPr>
+                <a:xfrm>
+                  <a:off x="5171114" y="1942216"/>
+                  <a:ext cx="1263721" cy="369332"/>
+                </a:xfrm>
+                <a:prstGeom prst="rect">
+                  <a:avLst/>
+                </a:prstGeom>
+                <a:noFill/>
+              </p:spPr>
+              <p:txBody>
+                <a:bodyPr wrap="square" rtlCol="0">
+                  <a:spAutoFit/>
+                </a:bodyPr>
+                <a:lstStyle/>
+                <a:p>
+                  <a14:m>
+                    <m:oMathPara xmlns:m="http://schemas.openxmlformats.org/officeDocument/2006/math">
+                      <m:oMathParaPr>
+                        <m:jc m:val="centerGroup"/>
+                      </m:oMathParaPr>
+                      <m:oMath xmlns:m="http://schemas.openxmlformats.org/officeDocument/2006/math">
+                        <m:sSub>
+                          <m:sSubPr>
+                            <m:ctrlPr>
+                              <a:rPr lang="en-US" b="0" i="1" dirty="0" smtClean="0">
+                                <a:solidFill>
+                                  <a:schemeClr val="accent1"/>
+                                </a:solidFill>
+                                <a:latin typeface="Cambria Math" panose="02040503050406030204" pitchFamily="18" charset="0"/>
+                              </a:rPr>
+                            </m:ctrlPr>
+                          </m:sSubPr>
+                          <m:e>
+                            <m:r>
+                              <a:rPr lang="en-US" b="0" i="1" dirty="0" smtClean="0">
+                                <a:solidFill>
+                                  <a:schemeClr val="accent1"/>
+                                </a:solidFill>
+                                <a:latin typeface="Cambria Math" panose="02040503050406030204" pitchFamily="18" charset="0"/>
+                              </a:rPr>
+                              <m:t>𝐹</m:t>
+                            </m:r>
+                          </m:e>
+                          <m:sub>
+                            <m:r>
+                              <a:rPr lang="en-US" b="0" i="1" dirty="0" smtClean="0">
+                                <a:solidFill>
+                                  <a:schemeClr val="accent1"/>
+                                </a:solidFill>
+                                <a:latin typeface="Cambria Math" panose="02040503050406030204" pitchFamily="18" charset="0"/>
+                              </a:rPr>
+                              <m:t>𝑏</m:t>
+                            </m:r>
+                          </m:sub>
+                        </m:sSub>
+                      </m:oMath>
+                    </m:oMathPara>
+                  </a14:m>
+                  <a:endParaRPr lang="en-US" b="0" dirty="0">
+                    <a:solidFill>
+                      <a:schemeClr val="accent1"/>
+                    </a:solidFill>
+                  </a:endParaRPr>
+                </a:p>
+              </p:txBody>
+            </p:sp>
+          </mc:Choice>
+          <mc:Fallback>
+            <p:sp>
+              <p:nvSpPr>
+                <p:cNvPr id="15" name="TextBox 14">
+                  <a:extLst>
+                    <a:ext uri="{FF2B5EF4-FFF2-40B4-BE49-F238E27FC236}">
+                      <a16:creationId xmlns:a16="http://schemas.microsoft.com/office/drawing/2014/main" id="{1BA5C519-A6F3-32B2-DE72-A19B249A3039}"/>
+                    </a:ext>
+                  </a:extLst>
+                </p:cNvPr>
+                <p:cNvSpPr txBox="1">
+                  <a:spLocks noRot="1" noChangeAspect="1" noMove="1" noResize="1" noEditPoints="1" noAdjustHandles="1" noChangeArrowheads="1" noChangeShapeType="1" noTextEdit="1"/>
+                </p:cNvSpPr>
+                <p:nvPr/>
+              </p:nvSpPr>
+              <p:spPr>
+                <a:xfrm>
+                  <a:off x="5171114" y="1942216"/>
+                  <a:ext cx="1263721" cy="369332"/>
+                </a:xfrm>
+                <a:prstGeom prst="rect">
+                  <a:avLst/>
+                </a:prstGeom>
+                <a:blipFill>
+                  <a:blip r:embed="rId3"/>
+                  <a:stretch>
+                    <a:fillRect/>
+                  </a:stretch>
+                </a:blipFill>
+              </p:spPr>
+              <p:txBody>
+                <a:bodyPr/>
+                <a:lstStyle/>
+                <a:p>
+                  <a:r>
+                    <a:rPr lang="en-US">
+                      <a:noFill/>
+                    </a:rPr>
+                    <a:t> </a:t>
+                  </a:r>
+                </a:p>
+              </p:txBody>
+            </p:sp>
+          </mc:Fallback>
+        </mc:AlternateContent>
         <p:sp>
           <p:nvSpPr>
-            <p:cNvPr id="18" name="Arrow: Curved Down 17">
-              <a:extLst>
-                <a:ext uri="{FF2B5EF4-FFF2-40B4-BE49-F238E27FC236}">
-                  <a16:creationId xmlns:a16="http://schemas.microsoft.com/office/drawing/2014/main" id="{6CE41918-056B-D9D6-9698-49AF35AA2931}"/>
+            <p:cNvPr id="20" name="Oval 19">
+              <a:extLst>
+                <a:ext uri="{FF2B5EF4-FFF2-40B4-BE49-F238E27FC236}">
+                  <a16:creationId xmlns:a16="http://schemas.microsoft.com/office/drawing/2014/main" id="{5FFCC9A5-B781-8A9A-4C32-FD66C7D4F940}"/>
                 </a:ext>
               </a:extLst>
             </p:cNvPr>
@@ -9229,10 +10027,10 @@
           </p:nvSpPr>
           <p:spPr>
             <a:xfrm>
-              <a:off x="5221356" y="1996254"/>
-              <a:ext cx="1457325" cy="385765"/>
-            </a:xfrm>
-            <a:prstGeom prst="curvedDownArrow">
+              <a:off x="5385066" y="3737584"/>
+              <a:ext cx="158145" cy="161924"/>
+            </a:xfrm>
+            <a:prstGeom prst="ellipse">
               <a:avLst/>
             </a:prstGeom>
           </p:spPr>
@@ -9257,7 +10055,53 @@
             <a:lstStyle/>
             <a:p>
               <a:pPr algn="ctr"/>
-              <a:endParaRPr lang="en-US">
+              <a:endParaRPr lang="en-US" sz="1799"/>
+            </a:p>
+          </p:txBody>
+        </p:sp>
+        <p:sp>
+          <p:nvSpPr>
+            <p:cNvPr id="21" name="Arrow: Curved Down 20">
+              <a:extLst>
+                <a:ext uri="{FF2B5EF4-FFF2-40B4-BE49-F238E27FC236}">
+                  <a16:creationId xmlns:a16="http://schemas.microsoft.com/office/drawing/2014/main" id="{062AF876-BCCE-3DDD-0758-147BFDDFD161}"/>
+                </a:ext>
+              </a:extLst>
+            </p:cNvPr>
+            <p:cNvSpPr/>
+            <p:nvPr/>
+          </p:nvSpPr>
+          <p:spPr>
+            <a:xfrm>
+              <a:off x="4619052" y="1574496"/>
+              <a:ext cx="1700684" cy="385765"/>
+            </a:xfrm>
+            <a:prstGeom prst="curvedDownArrow">
+              <a:avLst/>
+            </a:prstGeom>
+          </p:spPr>
+          <p:style>
+            <a:lnRef idx="2">
+              <a:schemeClr val="accent6">
+                <a:shade val="15000"/>
+              </a:schemeClr>
+            </a:lnRef>
+            <a:fillRef idx="1">
+              <a:schemeClr val="accent6"/>
+            </a:fillRef>
+            <a:effectRef idx="0">
+              <a:schemeClr val="accent6"/>
+            </a:effectRef>
+            <a:fontRef idx="minor">
+              <a:schemeClr val="lt1"/>
+            </a:fontRef>
+          </p:style>
+          <p:txBody>
+            <a:bodyPr rtlCol="0" anchor="ctr"/>
+            <a:lstStyle/>
+            <a:p>
+              <a:pPr algn="ctr"/>
+              <a:endParaRPr lang="en-US" sz="1799">
                 <a:solidFill>
                   <a:schemeClr val="tx1"/>
                 </a:solidFill>
@@ -9265,11 +10109,85 @@
             </a:p>
           </p:txBody>
         </p:sp>
+        <p:cxnSp>
+          <p:nvCxnSpPr>
+            <p:cNvPr id="22" name="Straight Connector 21">
+              <a:extLst>
+                <a:ext uri="{FF2B5EF4-FFF2-40B4-BE49-F238E27FC236}">
+                  <a16:creationId xmlns:a16="http://schemas.microsoft.com/office/drawing/2014/main" id="{0D1FBB14-F0E2-EE4D-4A31-ACFA072B2358}"/>
+                </a:ext>
+              </a:extLst>
+            </p:cNvPr>
+            <p:cNvCxnSpPr>
+              <a:cxnSpLocks/>
+            </p:cNvCxnSpPr>
+            <p:nvPr/>
+          </p:nvCxnSpPr>
+          <p:spPr>
+            <a:xfrm>
+              <a:off x="4236166" y="1497225"/>
+              <a:ext cx="2967845" cy="0"/>
+            </a:xfrm>
+            <a:prstGeom prst="line">
+              <a:avLst/>
+            </a:prstGeom>
+            <a:ln w="38100"/>
+          </p:spPr>
+          <p:style>
+            <a:lnRef idx="2">
+              <a:schemeClr val="accent1"/>
+            </a:lnRef>
+            <a:fillRef idx="0">
+              <a:schemeClr val="accent1"/>
+            </a:fillRef>
+            <a:effectRef idx="1">
+              <a:schemeClr val="accent1"/>
+            </a:effectRef>
+            <a:fontRef idx="minor">
+              <a:schemeClr val="tx1"/>
+            </a:fontRef>
+          </p:style>
+        </p:cxnSp>
+        <p:sp>
+          <p:nvSpPr>
+            <p:cNvPr id="25" name="TextBox 24">
+              <a:extLst>
+                <a:ext uri="{FF2B5EF4-FFF2-40B4-BE49-F238E27FC236}">
+                  <a16:creationId xmlns:a16="http://schemas.microsoft.com/office/drawing/2014/main" id="{EBF77D3A-DAF2-024C-80D2-5C40F9F53FDE}"/>
+                </a:ext>
+              </a:extLst>
+            </p:cNvPr>
+            <p:cNvSpPr txBox="1"/>
+            <p:nvPr/>
+          </p:nvSpPr>
+          <p:spPr>
+            <a:xfrm>
+              <a:off x="4134103" y="1182003"/>
+              <a:ext cx="1921264" cy="369204"/>
+            </a:xfrm>
+            <a:prstGeom prst="rect">
+              <a:avLst/>
+            </a:prstGeom>
+            <a:noFill/>
+          </p:spPr>
+          <p:txBody>
+            <a:bodyPr wrap="square" rtlCol="0">
+              <a:spAutoFit/>
+            </a:bodyPr>
+            <a:lstStyle/>
+            <a:p>
+              <a:r>
+                <a:rPr lang="en-US" sz="1799" dirty="0"/>
+                <a:t>still water line</a:t>
+              </a:r>
+            </a:p>
+          </p:txBody>
+        </p:sp>
       </p:grpSp>
     </p:spTree>
     <p:extLst>
       <p:ext uri="{BB962C8B-B14F-4D97-AF65-F5344CB8AC3E}">
-        <p14:creationId xmlns:p14="http://schemas.microsoft.com/office/powerpoint/2010/main" val="103456040"/>
+        <p14:creationId xmlns:p14="http://schemas.microsoft.com/office/powerpoint/2010/main" val="1351272952"/>
       </p:ext>
     </p:extLst>
   </p:cSld>

</xml_diff>

<commit_message>
Update examples for OCEANS paper
</commit_message>
<xml_diff>
--- a/examples/FOSWEC_M4E/FOSWEC_BEM_Dimensions.pptx
+++ b/examples/FOSWEC_M4E/FOSWEC_BEM_Dimensions.pptx
@@ -263,7 +263,7 @@
           <a:p>
             <a:fld id="{DC3DD596-B551-4104-AF86-405EBC7207B6}" type="datetimeFigureOut">
               <a:rPr lang="en-US" smtClean="0"/>
-              <a:t>7/31/2026</a:t>
+              <a:t>8/18/2026</a:t>
             </a:fld>
             <a:endParaRPr lang="en-US"/>
           </a:p>
@@ -461,7 +461,7 @@
           <a:p>
             <a:fld id="{DC3DD596-B551-4104-AF86-405EBC7207B6}" type="datetimeFigureOut">
               <a:rPr lang="en-US" smtClean="0"/>
-              <a:t>7/31/2026</a:t>
+              <a:t>8/18/2026</a:t>
             </a:fld>
             <a:endParaRPr lang="en-US"/>
           </a:p>
@@ -669,7 +669,7 @@
           <a:p>
             <a:fld id="{DC3DD596-B551-4104-AF86-405EBC7207B6}" type="datetimeFigureOut">
               <a:rPr lang="en-US" smtClean="0"/>
-              <a:t>7/31/2026</a:t>
+              <a:t>8/18/2026</a:t>
             </a:fld>
             <a:endParaRPr lang="en-US"/>
           </a:p>
@@ -867,7 +867,7 @@
           <a:p>
             <a:fld id="{DC3DD596-B551-4104-AF86-405EBC7207B6}" type="datetimeFigureOut">
               <a:rPr lang="en-US" smtClean="0"/>
-              <a:t>7/31/2026</a:t>
+              <a:t>8/18/2026</a:t>
             </a:fld>
             <a:endParaRPr lang="en-US"/>
           </a:p>
@@ -1142,7 +1142,7 @@
           <a:p>
             <a:fld id="{DC3DD596-B551-4104-AF86-405EBC7207B6}" type="datetimeFigureOut">
               <a:rPr lang="en-US" smtClean="0"/>
-              <a:t>7/31/2026</a:t>
+              <a:t>8/18/2026</a:t>
             </a:fld>
             <a:endParaRPr lang="en-US"/>
           </a:p>
@@ -1407,7 +1407,7 @@
           <a:p>
             <a:fld id="{DC3DD596-B551-4104-AF86-405EBC7207B6}" type="datetimeFigureOut">
               <a:rPr lang="en-US" smtClean="0"/>
-              <a:t>7/31/2026</a:t>
+              <a:t>8/18/2026</a:t>
             </a:fld>
             <a:endParaRPr lang="en-US"/>
           </a:p>
@@ -1819,7 +1819,7 @@
           <a:p>
             <a:fld id="{DC3DD596-B551-4104-AF86-405EBC7207B6}" type="datetimeFigureOut">
               <a:rPr lang="en-US" smtClean="0"/>
-              <a:t>7/31/2026</a:t>
+              <a:t>8/18/2026</a:t>
             </a:fld>
             <a:endParaRPr lang="en-US"/>
           </a:p>
@@ -1960,7 +1960,7 @@
           <a:p>
             <a:fld id="{DC3DD596-B551-4104-AF86-405EBC7207B6}" type="datetimeFigureOut">
               <a:rPr lang="en-US" smtClean="0"/>
-              <a:t>7/31/2026</a:t>
+              <a:t>8/18/2026</a:t>
             </a:fld>
             <a:endParaRPr lang="en-US"/>
           </a:p>
@@ -2073,7 +2073,7 @@
           <a:p>
             <a:fld id="{DC3DD596-B551-4104-AF86-405EBC7207B6}" type="datetimeFigureOut">
               <a:rPr lang="en-US" smtClean="0"/>
-              <a:t>7/31/2026</a:t>
+              <a:t>8/18/2026</a:t>
             </a:fld>
             <a:endParaRPr lang="en-US"/>
           </a:p>
@@ -2384,7 +2384,7 @@
           <a:p>
             <a:fld id="{DC3DD596-B551-4104-AF86-405EBC7207B6}" type="datetimeFigureOut">
               <a:rPr lang="en-US" smtClean="0"/>
-              <a:t>7/31/2026</a:t>
+              <a:t>8/18/2026</a:t>
             </a:fld>
             <a:endParaRPr lang="en-US"/>
           </a:p>
@@ -2672,7 +2672,7 @@
           <a:p>
             <a:fld id="{DC3DD596-B551-4104-AF86-405EBC7207B6}" type="datetimeFigureOut">
               <a:rPr lang="en-US" smtClean="0"/>
-              <a:t>7/31/2026</a:t>
+              <a:t>8/18/2026</a:t>
             </a:fld>
             <a:endParaRPr lang="en-US"/>
           </a:p>
@@ -2913,7 +2913,7 @@
           <a:p>
             <a:fld id="{DC3DD596-B551-4104-AF86-405EBC7207B6}" type="datetimeFigureOut">
               <a:rPr lang="en-US" smtClean="0"/>
-              <a:t>7/31/2026</a:t>
+              <a:t>8/18/2026</a:t>
             </a:fld>
             <a:endParaRPr lang="en-US"/>
           </a:p>
@@ -8506,7 +8506,9 @@
                   <a:avLst/>
                 </a:prstGeom>
                 <a:solidFill>
-                  <a:schemeClr val="bg1"/>
+                  <a:schemeClr val="bg2">
+                    <a:lumMod val="75000"/>
+                  </a:schemeClr>
                 </a:solidFill>
                 <a:ln w="28575">
                   <a:solidFill>
@@ -8562,7 +8564,9 @@
                   <a:avLst/>
                 </a:prstGeom>
                 <a:solidFill>
-                  <a:schemeClr val="bg1"/>
+                  <a:schemeClr val="bg2">
+                    <a:lumMod val="75000"/>
+                  </a:schemeClr>
                 </a:solidFill>
                 <a:ln w="28575">
                   <a:solidFill>
@@ -8593,7 +8597,7 @@
                 <a:lstStyle/>
                 <a:p>
                   <a:pPr algn="ctr"/>
-                  <a:endParaRPr lang="en-US" sz="1799"/>
+                  <a:endParaRPr lang="en-US" sz="1799" dirty="0"/>
                 </a:p>
               </p:txBody>
             </p:sp>
@@ -9518,7 +9522,7 @@
           </p:nvSpPr>
           <p:spPr>
             <a:xfrm rot="1529856">
-              <a:off x="5897630" y="2702641"/>
+              <a:off x="5875370" y="2695499"/>
               <a:ext cx="142875" cy="204788"/>
             </a:xfrm>
             <a:prstGeom prst="ellipse">
@@ -9602,8 +9606,8 @@
             <p:nvPr/>
           </p:nvSpPr>
           <p:spPr>
-            <a:xfrm>
-              <a:off x="5923401" y="2384743"/>
+            <a:xfrm rot="1422371">
+              <a:off x="5984612" y="2424176"/>
               <a:ext cx="172599" cy="224282"/>
             </a:xfrm>
             <a:prstGeom prst="ellipse">
@@ -9649,8 +9653,8 @@
           </p:nvSpPr>
           <p:spPr>
             <a:xfrm>
-              <a:off x="5464139" y="2293272"/>
-              <a:ext cx="1263721" cy="369332"/>
+              <a:off x="5526226" y="2334174"/>
+              <a:ext cx="504928" cy="369332"/>
             </a:xfrm>
             <a:prstGeom prst="rect">
               <a:avLst/>
@@ -9688,13 +9692,15 @@
                 </a:ext>
               </a:extLst>
             </p:cNvPr>
-            <p:cNvCxnSpPr/>
+            <p:cNvCxnSpPr>
+              <a:cxnSpLocks/>
+            </p:cNvCxnSpPr>
             <p:nvPr/>
           </p:nvCxnSpPr>
           <p:spPr>
             <a:xfrm flipV="1">
-              <a:off x="6009700" y="1756881"/>
-              <a:ext cx="0" cy="740003"/>
+              <a:off x="6076684" y="1812448"/>
+              <a:ext cx="0" cy="731475"/>
             </a:xfrm>
             <a:prstGeom prst="straightConnector1">
               <a:avLst/>
@@ -9759,8 +9765,8 @@
             </a:fontRef>
           </p:style>
         </p:cxnSp>
-        <mc:AlternateContent xmlns:mc="http://schemas.openxmlformats.org/markup-compatibility/2006">
-          <mc:Choice xmlns:a14="http://schemas.microsoft.com/office/drawing/2010/main" Requires="a14">
+        <mc:AlternateContent xmlns:mc="http://schemas.openxmlformats.org/markup-compatibility/2006" xmlns:a14="http://schemas.microsoft.com/office/drawing/2010/main">
+          <mc:Choice Requires="a14">
             <p:sp>
               <p:nvSpPr>
                 <p:cNvPr id="14" name="TextBox 13">
@@ -9789,6 +9795,7 @@
                 </a:bodyPr>
                 <a:lstStyle/>
                 <a:p>
+                  <a:pPr/>
                   <a14:m>
                     <m:oMathPara xmlns:m="http://schemas.openxmlformats.org/officeDocument/2006/math">
                       <m:oMathParaPr>
@@ -9841,7 +9848,7 @@
               </p:txBody>
             </p:sp>
           </mc:Choice>
-          <mc:Fallback>
+          <mc:Fallback xmlns="">
             <p:sp>
               <p:nvSpPr>
                 <p:cNvPr id="14" name="TextBox 13">
@@ -9902,7 +9909,7 @@
               </p:nvSpPr>
               <p:spPr>
                 <a:xfrm>
-                  <a:off x="5171114" y="1942216"/>
+                  <a:off x="5221335" y="1954335"/>
                   <a:ext cx="1263721" cy="369332"/>
                 </a:xfrm>
                 <a:prstGeom prst="rect">
@@ -9916,6 +9923,7 @@
                 </a:bodyPr>
                 <a:lstStyle/>
                 <a:p>
+                  <a:pPr/>
                   <a14:m>
                     <m:oMathPara xmlns:m="http://schemas.openxmlformats.org/officeDocument/2006/math">
                       <m:oMathParaPr>
@@ -9985,7 +9993,7 @@
               </p:nvSpPr>
               <p:spPr>
                 <a:xfrm>
-                  <a:off x="5171114" y="1942216"/>
+                  <a:off x="5221335" y="1954335"/>
                   <a:ext cx="1263721" cy="369332"/>
                 </a:xfrm>
                 <a:prstGeom prst="rect">

</xml_diff>